<commit_message>
Expand product pitch with video media and per-product use cases.
Ship selective-interface video on TAP method slides, full config-space art, and one use-case slide per product so the deck stays readable without scroll. Also polish SalesSlideDeck media layout and related orbit coach/demo and pitch content updates.
</commit_message>
<xml_diff>
--- a/docs/pitch/product-pitch.pptx
+++ b/docs/pitch/product-pitch.pptx
@@ -9,9 +9,10 @@
     <p:sldId id="257" r:id="rId3"/>
     <p:sldId id="258" r:id="rId4"/>
     <p:sldId id="259" r:id="rId5"/>
+    <p:sldId id="260" r:id="rId6"/>
   </p:sldIdLst>
   <p:notesMasterIdLst>
-    <p:notesMasterId r:id="rId6"/>
+    <p:notesMasterId r:id="rId7"/>
   </p:notesMasterIdLst>
   <p:sldSz cx="9144000" cy="5143500"/>
   <p:notesSz cx="5143500" cy="9144000"/>
@@ -811,6 +812,94 @@
 </p:notes>
 </file>
 
+<file path=ppt/notesSlides/notesSlide5.xml><?xml version="1.0" encoding="utf-8"?>
+<p:notes xmlns:a="http://schemas.openxmlformats.org/drawingml/2006/main" xmlns:r="http://schemas.openxmlformats.org/officeDocument/2006/relationships" xmlns:p="http://schemas.openxmlformats.org/presentationml/2006/main">
+  <p:cSld>
+    <p:spTree>
+      <p:nvGrpSpPr>
+        <p:cNvPr id="1" name=""/>
+        <p:cNvGrpSpPr/>
+        <p:nvPr/>
+      </p:nvGrpSpPr>
+      <p:grpSpPr>
+        <a:xfrm>
+          <a:off x="0" y="0"/>
+          <a:ext cx="0" cy="0"/>
+          <a:chOff x="0" y="0"/>
+          <a:chExt cx="0" cy="0"/>
+        </a:xfrm>
+      </p:grpSpPr>
+      <p:sp>
+        <p:nvSpPr>
+          <p:cNvPr id="2" name="Slide Image Placeholder 1"/>
+          <p:cNvSpPr>
+            <a:spLocks noGrp="1" noRot="1" noChangeAspect="1"/>
+          </p:cNvSpPr>
+          <p:nvPr>
+            <p:ph type="sldImg"/>
+          </p:nvPr>
+        </p:nvSpPr>
+        <p:spPr/>
+      </p:sp>
+      <p:sp>
+        <p:nvSpPr>
+          <p:cNvPr id="3" name="Notes Placeholder 2"/>
+          <p:cNvSpPr>
+            <a:spLocks noGrp="1"/>
+          </p:cNvSpPr>
+          <p:nvPr>
+            <p:ph type="body" idx="1"/>
+          </p:nvPr>
+        </p:nvSpPr>
+        <p:spPr/>
+        <p:txBody>
+          <a:bodyPr/>
+          <a:lstStyle/>
+          <a:p>
+            <a:r>
+              <a:rPr lang="en-US" dirty="0"/>
+              <a:t/>
+            </a:r>
+            <a:endParaRPr lang="en-US" dirty="0"/>
+          </a:p>
+        </p:txBody>
+      </p:sp>
+      <p:sp>
+        <p:nvSpPr>
+          <p:cNvPr id="4" name="Slide Number Placeholder 3"/>
+          <p:cNvSpPr>
+            <a:spLocks noGrp="1"/>
+          </p:cNvSpPr>
+          <p:nvPr>
+            <p:ph type="sldNum" sz="quarter" idx="10"/>
+          </p:nvPr>
+        </p:nvSpPr>
+        <p:spPr/>
+        <p:txBody>
+          <a:bodyPr/>
+          <a:lstStyle/>
+          <a:p>
+            <a:fld id="{F7021451-1387-4CA6-816F-3879F97B5CBC}" type="slidenum">
+              <a:rPr lang="en-US"/>
+              <a:t>5</a:t>
+            </a:fld>
+            <a:endParaRPr lang="en-US"/>
+          </a:p>
+        </p:txBody>
+      </p:sp>
+    </p:spTree>
+    <p:extLst>
+      <p:ext uri="{BB962C8B-B14F-4D97-AF65-F5344CB8AC3E}">
+        <p14:creationId xmlns:p14="http://schemas.microsoft.com/office/powerpoint/2010/main" val="1024086991"/>
+      </p:ext>
+    </p:extLst>
+  </p:cSld>
+  <p:clrMapOvr>
+    <a:masterClrMapping/>
+  </p:clrMapOvr>
+</p:notes>
+</file>
+
 <file path=ppt/slideLayouts/slideLayout1.xml><?xml version="1.0" encoding="utf-8"?>
 <p:sldLayout xmlns:a="http://schemas.openxmlformats.org/drawingml/2006/main" xmlns:r="http://schemas.openxmlformats.org/officeDocument/2006/relationships" xmlns:p="http://schemas.openxmlformats.org/presentationml/2006/main" preserve="1">
   <p:cSld name="DEFAULT">
@@ -1232,7 +1321,7 @@
                 <a:ea typeface="Consolas" pitchFamily="34" charset="-122"/>
                 <a:cs typeface="Consolas" pitchFamily="34" charset="-120"/>
               </a:rPr>
-              <a:t>01 / 04</a:t>
+              <a:t>01 / 05</a:t>
             </a:r>
             <a:endParaRPr lang="en-US" sz="1000" dirty="0"/>
           </a:p>
@@ -1868,7 +1957,7 @@
                 <a:ea typeface="Consolas" pitchFamily="34" charset="-122"/>
                 <a:cs typeface="Consolas" pitchFamily="34" charset="-120"/>
               </a:rPr>
-              <a:t>02 / 04</a:t>
+              <a:t>02 / 05</a:t>
             </a:r>
             <a:endParaRPr lang="en-US" sz="1000" dirty="0"/>
           </a:p>
@@ -2036,7 +2125,7 @@
                 <a:ea typeface="Consolas" pitchFamily="34" charset="-122"/>
                 <a:cs typeface="Consolas" pitchFamily="34" charset="-120"/>
               </a:rPr>
-              <a:t>Stack / cognition layers</a:t>
+              <a:t>PoW + cognition layers</a:t>
             </a:r>
             <a:endParaRPr lang="en-US" sz="1100" dirty="0"/>
           </a:p>
@@ -2090,11 +2179,11 @@
         <p:spPr>
           <a:xfrm>
             <a:off x="411480" y="1417320"/>
-            <a:ext cx="4818888" cy="987552"/>
+            <a:ext cx="4818888" cy="1417320"/>
           </a:xfrm>
           <a:prstGeom prst="roundRect">
             <a:avLst>
-              <a:gd name="adj" fmla="val 7407"/>
+              <a:gd name="adj" fmla="val 5161"/>
             </a:avLst>
           </a:prstGeom>
           <a:solidFill>
@@ -2116,12 +2205,12 @@
         </p:nvSpPr>
         <p:spPr>
           <a:xfrm>
-            <a:off x="539496" y="1673352"/>
-            <a:ext cx="438912" cy="438912"/>
+            <a:off x="576072" y="1888236"/>
+            <a:ext cx="475488" cy="475488"/>
           </a:xfrm>
           <a:prstGeom prst="roundRect">
             <a:avLst>
-              <a:gd name="adj" fmla="val 12500"/>
+              <a:gd name="adj" fmla="val 11538"/>
             </a:avLst>
           </a:prstGeom>
           <a:solidFill>
@@ -2143,8 +2232,8 @@
         </p:nvSpPr>
         <p:spPr>
           <a:xfrm>
-            <a:off x="539496" y="1673352"/>
-            <a:ext cx="438912" cy="438912"/>
+            <a:off x="576072" y="1888236"/>
+            <a:ext cx="475488" cy="475488"/>
           </a:xfrm>
           <a:prstGeom prst="rect">
             <a:avLst/>
@@ -2160,7 +2249,7 @@
               <a:buNone/>
             </a:pPr>
             <a:r>
-              <a:rPr lang="en-US" sz="1100" b="1" dirty="0">
+              <a:rPr lang="en-US" sz="1200" b="1" dirty="0">
                 <a:solidFill>
                   <a:srgbClr val="7C9CFF"/>
                 </a:solidFill>
@@ -2170,7 +2259,7 @@
               </a:rPr>
               <a:t>01</a:t>
             </a:r>
-            <a:endParaRPr lang="en-US" sz="1100" dirty="0"/>
+            <a:endParaRPr lang="en-US" sz="1200" dirty="0"/>
           </a:p>
         </p:txBody>
       </p:sp>
@@ -2182,8 +2271,8 @@
         </p:nvSpPr>
         <p:spPr>
           <a:xfrm>
-            <a:off x="1124712" y="1563624"/>
-            <a:ext cx="3904488" cy="292608"/>
+            <a:off x="1234440" y="1618488"/>
+            <a:ext cx="3767328" cy="329184"/>
           </a:xfrm>
           <a:prstGeom prst="rect">
             <a:avLst/>
@@ -2199,7 +2288,7 @@
               <a:buNone/>
             </a:pPr>
             <a:r>
-              <a:rPr lang="en-US" sz="1500" b="1" dirty="0">
+              <a:rPr lang="en-US" sz="1700" b="1" dirty="0">
                 <a:solidFill>
                   <a:srgbClr val="FFFFFF"/>
                 </a:solidFill>
@@ -2209,7 +2298,7 @@
               </a:rPr>
               <a:t>Proof of Work</a:t>
             </a:r>
-            <a:endParaRPr lang="en-US" sz="1500" dirty="0"/>
+            <a:endParaRPr lang="en-US" sz="1700" dirty="0"/>
           </a:p>
         </p:txBody>
       </p:sp>
@@ -2221,24 +2310,24 @@
         </p:nvSpPr>
         <p:spPr>
           <a:xfrm>
-            <a:off x="1124712" y="1874520"/>
-            <a:ext cx="3904488" cy="438912"/>
-          </a:xfrm>
-          <a:prstGeom prst="rect">
-            <a:avLst/>
-          </a:prstGeom>
-          <a:noFill/>
-          <a:ln/>
-        </p:spPr>
-        <p:txBody>
-          <a:bodyPr wrap="square" lIns="0" tIns="0" rIns="0" bIns="0" rtlCol="0" anchor="ctr"/>
+            <a:off x="1234440" y="1984248"/>
+            <a:ext cx="3767328" cy="667512"/>
+          </a:xfrm>
+          <a:prstGeom prst="rect">
+            <a:avLst/>
+          </a:prstGeom>
+          <a:noFill/>
+          <a:ln/>
+        </p:spPr>
+        <p:txBody>
+          <a:bodyPr wrap="square" lIns="0" tIns="0" rIns="0" bIns="0" rtlCol="0" anchor="t"/>
           <a:lstStyle/>
           <a:p>
             <a:pPr indent="0" marL="0">
               <a:buNone/>
             </a:pPr>
             <a:r>
-              <a:rPr lang="en-US" sz="1200" dirty="0">
+              <a:rPr lang="en-US" sz="1300" dirty="0">
                 <a:solidFill>
                   <a:srgbClr val="8B93A7"/>
                 </a:solidFill>
@@ -2248,7 +2337,7 @@
               </a:rPr>
               <a:t>Basis layer. Artifacts, tool traces, and think-aloud — evidence of work, not a multiple-choice snapshot.</a:t>
             </a:r>
-            <a:endParaRPr lang="en-US" sz="1200" dirty="0"/>
+            <a:endParaRPr lang="en-US" sz="1300" dirty="0"/>
           </a:p>
         </p:txBody>
       </p:sp>
@@ -2260,12 +2349,12 @@
         </p:nvSpPr>
         <p:spPr>
           <a:xfrm>
-            <a:off x="411480" y="2514600"/>
-            <a:ext cx="4818888" cy="987552"/>
+            <a:off x="411480" y="3017520"/>
+            <a:ext cx="4818888" cy="1417320"/>
           </a:xfrm>
           <a:prstGeom prst="roundRect">
             <a:avLst>
-              <a:gd name="adj" fmla="val 7407"/>
+              <a:gd name="adj" fmla="val 5161"/>
             </a:avLst>
           </a:prstGeom>
           <a:solidFill>
@@ -2287,12 +2376,12 @@
         </p:nvSpPr>
         <p:spPr>
           <a:xfrm>
-            <a:off x="539496" y="2770632"/>
-            <a:ext cx="438912" cy="438912"/>
+            <a:off x="576072" y="3488436"/>
+            <a:ext cx="475488" cy="475488"/>
           </a:xfrm>
           <a:prstGeom prst="roundRect">
             <a:avLst>
-              <a:gd name="adj" fmla="val 12500"/>
+              <a:gd name="adj" fmla="val 11538"/>
             </a:avLst>
           </a:prstGeom>
           <a:solidFill>
@@ -2314,8 +2403,8 @@
         </p:nvSpPr>
         <p:spPr>
           <a:xfrm>
-            <a:off x="539496" y="2770632"/>
-            <a:ext cx="438912" cy="438912"/>
+            <a:off x="576072" y="3488436"/>
+            <a:ext cx="475488" cy="475488"/>
           </a:xfrm>
           <a:prstGeom prst="rect">
             <a:avLst/>
@@ -2331,7 +2420,7 @@
               <a:buNone/>
             </a:pPr>
             <a:r>
-              <a:rPr lang="en-US" sz="1100" b="1" dirty="0">
+              <a:rPr lang="en-US" sz="1200" b="1" dirty="0">
                 <a:solidFill>
                   <a:srgbClr val="6BCB9A"/>
                 </a:solidFill>
@@ -2341,7 +2430,7 @@
               </a:rPr>
               <a:t>02</a:t>
             </a:r>
-            <a:endParaRPr lang="en-US" sz="1100" dirty="0"/>
+            <a:endParaRPr lang="en-US" sz="1200" dirty="0"/>
           </a:p>
         </p:txBody>
       </p:sp>
@@ -2353,8 +2442,8 @@
         </p:nvSpPr>
         <p:spPr>
           <a:xfrm>
-            <a:off x="1124712" y="2660904"/>
-            <a:ext cx="3904488" cy="292608"/>
+            <a:off x="1234440" y="3218688"/>
+            <a:ext cx="3767328" cy="329184"/>
           </a:xfrm>
           <a:prstGeom prst="rect">
             <a:avLst/>
@@ -2370,7 +2459,7 @@
               <a:buNone/>
             </a:pPr>
             <a:r>
-              <a:rPr lang="en-US" sz="1500" b="1" dirty="0">
+              <a:rPr lang="en-US" sz="1700" b="1" dirty="0">
                 <a:solidFill>
                   <a:srgbClr val="FFFFFF"/>
                 </a:solidFill>
@@ -2380,7 +2469,7 @@
               </a:rPr>
               <a:t>Genuine Human Cognition Analysis</a:t>
             </a:r>
-            <a:endParaRPr lang="en-US" sz="1500" dirty="0"/>
+            <a:endParaRPr lang="en-US" sz="1700" dirty="0"/>
           </a:p>
         </p:txBody>
       </p:sp>
@@ -2392,24 +2481,24 @@
         </p:nvSpPr>
         <p:spPr>
           <a:xfrm>
-            <a:off x="1124712" y="2971800"/>
-            <a:ext cx="3904488" cy="438912"/>
-          </a:xfrm>
-          <a:prstGeom prst="rect">
-            <a:avLst/>
-          </a:prstGeom>
-          <a:noFill/>
-          <a:ln/>
-        </p:spPr>
-        <p:txBody>
-          <a:bodyPr wrap="square" lIns="0" tIns="0" rIns="0" bIns="0" rtlCol="0" anchor="ctr"/>
+            <a:off x="1234440" y="3584448"/>
+            <a:ext cx="3767328" cy="667512"/>
+          </a:xfrm>
+          <a:prstGeom prst="rect">
+            <a:avLst/>
+          </a:prstGeom>
+          <a:noFill/>
+          <a:ln/>
+        </p:spPr>
+        <p:txBody>
+          <a:bodyPr wrap="square" lIns="0" tIns="0" rIns="0" bIns="0" rtlCol="0" anchor="t"/>
           <a:lstStyle/>
           <a:p>
             <a:pPr indent="0" marL="0">
               <a:buNone/>
             </a:pPr>
             <a:r>
-              <a:rPr lang="en-US" sz="1200" dirty="0">
+              <a:rPr lang="en-US" sz="1300" dirty="0">
                 <a:solidFill>
                   <a:srgbClr val="8B93A7"/>
                 </a:solidFill>
@@ -2419,178 +2508,7 @@
               </a:rPr>
               <a:t>Chain-of-thought linearity analysis. How we capture thought is decisive — Selective Thought Interface.</a:t>
             </a:r>
-            <a:endParaRPr lang="en-US" sz="1200" dirty="0"/>
-          </a:p>
-        </p:txBody>
-      </p:sp>
-      <p:sp>
-        <p:nvSpPr>
-          <p:cNvPr id="21" name="Shape 19"/>
-          <p:cNvSpPr/>
-          <p:nvPr/>
-        </p:nvSpPr>
-        <p:spPr>
-          <a:xfrm>
-            <a:off x="411480" y="3611880"/>
-            <a:ext cx="4818888" cy="987552"/>
-          </a:xfrm>
-          <a:prstGeom prst="roundRect">
-            <a:avLst>
-              <a:gd name="adj" fmla="val 7407"/>
-            </a:avLst>
-          </a:prstGeom>
-          <a:solidFill>
-            <a:srgbClr val="181C26"/>
-          </a:solidFill>
-          <a:ln w="12700">
-            <a:solidFill>
-              <a:srgbClr val="2A3142"/>
-            </a:solidFill>
-            <a:prstDash val="solid"/>
-          </a:ln>
-        </p:spPr>
-      </p:sp>
-      <p:sp>
-        <p:nvSpPr>
-          <p:cNvPr id="22" name="Shape 20"/>
-          <p:cNvSpPr/>
-          <p:nvPr/>
-        </p:nvSpPr>
-        <p:spPr>
-          <a:xfrm>
-            <a:off x="539496" y="3867912"/>
-            <a:ext cx="438912" cy="438912"/>
-          </a:xfrm>
-          <a:prstGeom prst="roundRect">
-            <a:avLst>
-              <a:gd name="adj" fmla="val 12500"/>
-            </a:avLst>
-          </a:prstGeom>
-          <a:solidFill>
-            <a:srgbClr val="1C2130"/>
-          </a:solidFill>
-          <a:ln w="12700">
-            <a:solidFill>
-              <a:srgbClr val="2A3142"/>
-            </a:solidFill>
-            <a:prstDash val="solid"/>
-          </a:ln>
-        </p:spPr>
-      </p:sp>
-      <p:sp>
-        <p:nvSpPr>
-          <p:cNvPr id="23" name="Text 21"/>
-          <p:cNvSpPr/>
-          <p:nvPr/>
-        </p:nvSpPr>
-        <p:spPr>
-          <a:xfrm>
-            <a:off x="539496" y="3867912"/>
-            <a:ext cx="438912" cy="438912"/>
-          </a:xfrm>
-          <a:prstGeom prst="rect">
-            <a:avLst/>
-          </a:prstGeom>
-          <a:noFill/>
-          <a:ln/>
-        </p:spPr>
-        <p:txBody>
-          <a:bodyPr wrap="square" lIns="0" tIns="0" rIns="0" bIns="0" rtlCol="0" anchor="ctr"/>
-          <a:lstStyle/>
-          <a:p>
-            <a:pPr algn="ctr" indent="0" marL="0">
-              <a:buNone/>
-            </a:pPr>
-            <a:r>
-              <a:rPr lang="en-US" sz="1100" b="1" dirty="0">
-                <a:solidFill>
-                  <a:srgbClr val="E8B86D"/>
-                </a:solidFill>
-                <a:latin typeface="Consolas" pitchFamily="34" charset="0"/>
-                <a:ea typeface="Consolas" pitchFamily="34" charset="-122"/>
-                <a:cs typeface="Consolas" pitchFamily="34" charset="-120"/>
-              </a:rPr>
-              <a:t>03</a:t>
-            </a:r>
-            <a:endParaRPr lang="en-US" sz="1100" dirty="0"/>
-          </a:p>
-        </p:txBody>
-      </p:sp>
-      <p:sp>
-        <p:nvSpPr>
-          <p:cNvPr id="24" name="Text 22"/>
-          <p:cNvSpPr/>
-          <p:nvPr/>
-        </p:nvSpPr>
-        <p:spPr>
-          <a:xfrm>
-            <a:off x="1124712" y="3758184"/>
-            <a:ext cx="3904488" cy="292608"/>
-          </a:xfrm>
-          <a:prstGeom prst="rect">
-            <a:avLst/>
-          </a:prstGeom>
-          <a:noFill/>
-          <a:ln/>
-        </p:spPr>
-        <p:txBody>
-          <a:bodyPr wrap="square" lIns="0" tIns="0" rIns="0" bIns="0" rtlCol="0" anchor="ctr"/>
-          <a:lstStyle/>
-          <a:p>
-            <a:pPr indent="0" marL="0">
-              <a:buNone/>
-            </a:pPr>
-            <a:r>
-              <a:rPr lang="en-US" sz="1500" b="1" dirty="0">
-                <a:solidFill>
-                  <a:srgbClr val="FFFFFF"/>
-                </a:solidFill>
-                <a:latin typeface="Calibri" pitchFamily="34" charset="0"/>
-                <a:ea typeface="Calibri" pitchFamily="34" charset="-122"/>
-                <a:cs typeface="Calibri" pitchFamily="34" charset="-120"/>
-              </a:rPr>
-              <a:t>Learning Model · Trace Interruptions</a:t>
-            </a:r>
-            <a:endParaRPr lang="en-US" sz="1500" dirty="0"/>
-          </a:p>
-        </p:txBody>
-      </p:sp>
-      <p:sp>
-        <p:nvSpPr>
-          <p:cNvPr id="25" name="Text 23"/>
-          <p:cNvSpPr/>
-          <p:nvPr/>
-        </p:nvSpPr>
-        <p:spPr>
-          <a:xfrm>
-            <a:off x="1124712" y="4069080"/>
-            <a:ext cx="3904488" cy="438912"/>
-          </a:xfrm>
-          <a:prstGeom prst="rect">
-            <a:avLst/>
-          </a:prstGeom>
-          <a:noFill/>
-          <a:ln/>
-        </p:spPr>
-        <p:txBody>
-          <a:bodyPr wrap="square" lIns="0" tIns="0" rIns="0" bIns="0" rtlCol="0" anchor="ctr"/>
-          <a:lstStyle/>
-          <a:p>
-            <a:pPr indent="0" marL="0">
-              <a:buNone/>
-            </a:pPr>
-            <a:r>
-              <a:rPr lang="en-US" sz="1200" dirty="0">
-                <a:solidFill>
-                  <a:srgbClr val="8B93A7"/>
-                </a:solidFill>
-                <a:latin typeface="Calibri" pitchFamily="34" charset="0"/>
-                <a:ea typeface="Calibri" pitchFamily="34" charset="-122"/>
-                <a:cs typeface="Calibri" pitchFamily="34" charset="-120"/>
-              </a:rPr>
-              <a:t>World-model style. Trace interruptions probe gaps mid-reasoning — and measure how interruption changes learning effectiveness.</a:t>
-            </a:r>
-            <a:endParaRPr lang="en-US" sz="1200" dirty="0"/>
+            <a:endParaRPr lang="en-US" sz="1300" dirty="0"/>
           </a:p>
         </p:txBody>
       </p:sp>
@@ -2677,7 +2595,7 @@
                 <a:ea typeface="Consolas" pitchFamily="34" charset="-122"/>
                 <a:cs typeface="Consolas" pitchFamily="34" charset="-120"/>
               </a:rPr>
-              <a:t>03  ·  PRODUCTIZED</a:t>
+              <a:t>03  ·  HOW WE TEST IT</a:t>
             </a:r>
             <a:endParaRPr lang="en-US" sz="1000" dirty="0"/>
           </a:p>
@@ -2716,7 +2634,7 @@
                 <a:ea typeface="Consolas" pitchFamily="34" charset="-122"/>
                 <a:cs typeface="Consolas" pitchFamily="34" charset="-120"/>
               </a:rPr>
-              <a:t>03 / 04</a:t>
+              <a:t>03 / 05</a:t>
             </a:r>
             <a:endParaRPr lang="en-US" sz="1000" dirty="0"/>
           </a:p>
@@ -2755,7 +2673,7 @@
                 <a:ea typeface="Calibri" pitchFamily="34" charset="-122"/>
                 <a:cs typeface="Calibri" pitchFamily="34" charset="-120"/>
               </a:rPr>
-              <a:t>Model surfaces in</a:t>
+              <a:t>The third layer: probe</a:t>
             </a:r>
             <a:endParaRPr lang="en-US" sz="2800" dirty="0"/>
           </a:p>
@@ -2772,7 +2690,7 @@
                 <a:ea typeface="Calibri" pitchFamily="34" charset="-122"/>
                 <a:cs typeface="Calibri" pitchFamily="34" charset="-120"/>
               </a:rPr>
-              <a:t>two product primitives.</a:t>
+              <a:t>gaps mid-reasoning.</a:t>
             </a:r>
             <a:endParaRPr lang="en-US" sz="2800" dirty="0"/>
           </a:p>
@@ -2884,7 +2802,7 @@
                 <a:ea typeface="Consolas" pitchFamily="34" charset="-122"/>
                 <a:cs typeface="Consolas" pitchFamily="34" charset="-120"/>
               </a:rPr>
-              <a:t>UI / interaction model</a:t>
+              <a:t>Trace interruptions</a:t>
             </a:r>
             <a:endParaRPr lang="en-US" sz="1100" dirty="0"/>
           </a:p>
@@ -2938,11 +2856,11 @@
         <p:spPr>
           <a:xfrm>
             <a:off x="411480" y="1417320"/>
-            <a:ext cx="4818888" cy="1554480"/>
+            <a:ext cx="4818888" cy="1691640"/>
           </a:xfrm>
           <a:prstGeom prst="roundRect">
             <a:avLst>
-              <a:gd name="adj" fmla="val 4706"/>
+              <a:gd name="adj" fmla="val 4324"/>
             </a:avLst>
           </a:prstGeom>
           <a:solidFill>
@@ -2958,139 +2876,22 @@
       </p:sp>
       <p:sp>
         <p:nvSpPr>
-          <p:cNvPr id="12" name="Text 10"/>
-          <p:cNvSpPr/>
-          <p:nvPr/>
-        </p:nvSpPr>
-        <p:spPr>
-          <a:xfrm>
-            <a:off x="612648" y="1554480"/>
-            <a:ext cx="4416552" cy="219456"/>
-          </a:xfrm>
-          <a:prstGeom prst="rect">
-            <a:avLst/>
-          </a:prstGeom>
-          <a:noFill/>
-          <a:ln/>
-        </p:spPr>
-        <p:txBody>
-          <a:bodyPr wrap="square" lIns="0" tIns="0" rIns="0" bIns="0" rtlCol="0" anchor="ctr"/>
-          <a:lstStyle/>
-          <a:p>
-            <a:pPr indent="0" marL="0">
-              <a:buNone/>
-            </a:pPr>
-            <a:r>
-              <a:rPr lang="en-US" sz="1000" b="1" spc="100" kern="0" dirty="0">
-                <a:solidFill>
-                  <a:srgbClr val="7C9CFF"/>
-                </a:solidFill>
-                <a:latin typeface="Consolas" pitchFamily="34" charset="0"/>
-                <a:ea typeface="Consolas" pitchFamily="34" charset="-122"/>
-                <a:cs typeface="Consolas" pitchFamily="34" charset="-120"/>
-              </a:rPr>
-              <a:t>PROOF OF WORK</a:t>
-            </a:r>
-            <a:endParaRPr lang="en-US" sz="1000" dirty="0"/>
-          </a:p>
-        </p:txBody>
-      </p:sp>
-      <p:sp>
-        <p:nvSpPr>
-          <p:cNvPr id="13" name="Text 11"/>
-          <p:cNvSpPr/>
-          <p:nvPr/>
-        </p:nvSpPr>
-        <p:spPr>
-          <a:xfrm>
-            <a:off x="612648" y="1828800"/>
-            <a:ext cx="4416552" cy="320040"/>
-          </a:xfrm>
-          <a:prstGeom prst="rect">
-            <a:avLst/>
-          </a:prstGeom>
-          <a:noFill/>
-          <a:ln/>
-        </p:spPr>
-        <p:txBody>
-          <a:bodyPr wrap="square" lIns="0" tIns="0" rIns="0" bIns="0" rtlCol="0" anchor="ctr"/>
-          <a:lstStyle/>
-          <a:p>
-            <a:pPr indent="0" marL="0">
-              <a:buNone/>
-            </a:pPr>
-            <a:r>
-              <a:rPr lang="en-US" sz="1800" b="1" dirty="0">
-                <a:solidFill>
-                  <a:srgbClr val="FFFFFF"/>
-                </a:solidFill>
-                <a:latin typeface="Calibri" pitchFamily="34" charset="0"/>
-                <a:ea typeface="Calibri" pitchFamily="34" charset="-122"/>
-                <a:cs typeface="Calibri" pitchFamily="34" charset="-120"/>
-              </a:rPr>
-              <a:t>Submit–Stash interaction</a:t>
-            </a:r>
-            <a:endParaRPr lang="en-US" sz="1800" dirty="0"/>
-          </a:p>
-        </p:txBody>
-      </p:sp>
-      <p:sp>
-        <p:nvSpPr>
-          <p:cNvPr id="14" name="Text 12"/>
-          <p:cNvSpPr/>
-          <p:nvPr/>
-        </p:nvSpPr>
-        <p:spPr>
-          <a:xfrm>
-            <a:off x="612648" y="2212848"/>
-            <a:ext cx="4416552" cy="548640"/>
-          </a:xfrm>
-          <a:prstGeom prst="rect">
-            <a:avLst/>
-          </a:prstGeom>
-          <a:noFill/>
-          <a:ln/>
-        </p:spPr>
-        <p:txBody>
-          <a:bodyPr wrap="square" lIns="0" tIns="0" rIns="0" bIns="0" rtlCol="0" anchor="ctr"/>
-          <a:lstStyle/>
-          <a:p>
-            <a:pPr indent="0" marL="0">
-              <a:buNone/>
-            </a:pPr>
-            <a:r>
-              <a:rPr lang="en-US" sz="1300" dirty="0">
-                <a:solidFill>
-                  <a:srgbClr val="8B93A7"/>
-                </a:solidFill>
-                <a:latin typeface="Calibri" pitchFamily="34" charset="0"/>
-                <a:ea typeface="Calibri" pitchFamily="34" charset="-122"/>
-                <a:cs typeface="Calibri" pitchFamily="34" charset="-120"/>
-              </a:rPr>
-              <a:t>Stream answers continuously. Learner (or agent) signals submit or stash — scoring attaches to intent, not just final paste.</a:t>
-            </a:r>
-            <a:endParaRPr lang="en-US" sz="1300" dirty="0"/>
-          </a:p>
-        </p:txBody>
-      </p:sp>
-      <p:sp>
-        <p:nvSpPr>
-          <p:cNvPr id="15" name="Shape 13"/>
-          <p:cNvSpPr/>
-          <p:nvPr/>
-        </p:nvSpPr>
-        <p:spPr>
-          <a:xfrm>
-            <a:off x="411480" y="3154680"/>
-            <a:ext cx="4818888" cy="1554480"/>
+          <p:cNvPr id="12" name="Shape 10"/>
+          <p:cNvSpPr/>
+          <p:nvPr/>
+        </p:nvSpPr>
+        <p:spPr>
+          <a:xfrm>
+            <a:off x="576072" y="2025396"/>
+            <a:ext cx="475488" cy="475488"/>
           </a:xfrm>
           <a:prstGeom prst="roundRect">
             <a:avLst>
-              <a:gd name="adj" fmla="val 4706"/>
+              <a:gd name="adj" fmla="val 11538"/>
             </a:avLst>
           </a:prstGeom>
           <a:solidFill>
-            <a:srgbClr val="181C26"/>
+            <a:srgbClr val="1C2130"/>
           </a:solidFill>
           <a:ln w="12700">
             <a:solidFill>
@@ -3102,14 +2903,14 @@
       </p:sp>
       <p:sp>
         <p:nvSpPr>
-          <p:cNvPr id="16" name="Text 14"/>
-          <p:cNvSpPr/>
-          <p:nvPr/>
-        </p:nvSpPr>
-        <p:spPr>
-          <a:xfrm>
-            <a:off x="612648" y="3291840"/>
-            <a:ext cx="4416552" cy="219456"/>
+          <p:cNvPr id="13" name="Text 11"/>
+          <p:cNvSpPr/>
+          <p:nvPr/>
+        </p:nvSpPr>
+        <p:spPr>
+          <a:xfrm>
+            <a:off x="576072" y="2025396"/>
+            <a:ext cx="475488" cy="475488"/>
           </a:xfrm>
           <a:prstGeom prst="rect">
             <a:avLst/>
@@ -3121,34 +2922,34 @@
           <a:bodyPr wrap="square" lIns="0" tIns="0" rIns="0" bIns="0" rtlCol="0" anchor="ctr"/>
           <a:lstStyle/>
           <a:p>
-            <a:pPr indent="0" marL="0">
-              <a:buNone/>
-            </a:pPr>
-            <a:r>
-              <a:rPr lang="en-US" sz="1000" b="1" spc="100" kern="0" dirty="0">
-                <a:solidFill>
-                  <a:srgbClr val="6BCB9A"/>
+            <a:pPr algn="ctr" indent="0" marL="0">
+              <a:buNone/>
+            </a:pPr>
+            <a:r>
+              <a:rPr lang="en-US" sz="1200" b="1" dirty="0">
+                <a:solidFill>
+                  <a:srgbClr val="E8B86D"/>
                 </a:solidFill>
                 <a:latin typeface="Consolas" pitchFamily="34" charset="0"/>
                 <a:ea typeface="Consolas" pitchFamily="34" charset="-122"/>
                 <a:cs typeface="Consolas" pitchFamily="34" charset="-120"/>
               </a:rPr>
-              <a:t>SELECTIVE THOUGHT INTERFACE</a:t>
-            </a:r>
-            <a:endParaRPr lang="en-US" sz="1000" dirty="0"/>
-          </a:p>
-        </p:txBody>
-      </p:sp>
-      <p:sp>
-        <p:nvSpPr>
-          <p:cNvPr id="17" name="Text 15"/>
-          <p:cNvSpPr/>
-          <p:nvPr/>
-        </p:nvSpPr>
-        <p:spPr>
-          <a:xfrm>
-            <a:off x="612648" y="3566160"/>
-            <a:ext cx="4416552" cy="320040"/>
+              <a:t>03</a:t>
+            </a:r>
+            <a:endParaRPr lang="en-US" sz="1200" dirty="0"/>
+          </a:p>
+        </p:txBody>
+      </p:sp>
+      <p:sp>
+        <p:nvSpPr>
+          <p:cNvPr id="14" name="Text 12"/>
+          <p:cNvSpPr/>
+          <p:nvPr/>
+        </p:nvSpPr>
+        <p:spPr>
+          <a:xfrm>
+            <a:off x="1234440" y="1618488"/>
+            <a:ext cx="3767328" cy="329184"/>
           </a:xfrm>
           <a:prstGeom prst="rect">
             <a:avLst/>
@@ -3164,7 +2965,7 @@
               <a:buNone/>
             </a:pPr>
             <a:r>
-              <a:rPr lang="en-US" sz="1800" b="1" dirty="0">
+              <a:rPr lang="en-US" sz="1700" b="1" dirty="0">
                 <a:solidFill>
                   <a:srgbClr val="FFFFFF"/>
                 </a:solidFill>
@@ -3172,31 +2973,31 @@
                 <a:ea typeface="Calibri" pitchFamily="34" charset="-122"/>
                 <a:cs typeface="Calibri" pitchFamily="34" charset="-120"/>
               </a:rPr>
-              <a:t>UI inside TAP &amp; ILE tools</a:t>
-            </a:r>
-            <a:endParaRPr lang="en-US" sz="1800" dirty="0"/>
-          </a:p>
-        </p:txBody>
-      </p:sp>
-      <p:sp>
-        <p:nvSpPr>
-          <p:cNvPr id="18" name="Text 16"/>
-          <p:cNvSpPr/>
-          <p:nvPr/>
-        </p:nvSpPr>
-        <p:spPr>
-          <a:xfrm>
-            <a:off x="612648" y="3950208"/>
-            <a:ext cx="4416552" cy="594360"/>
-          </a:xfrm>
-          <a:prstGeom prst="rect">
-            <a:avLst/>
-          </a:prstGeom>
-          <a:noFill/>
-          <a:ln/>
-        </p:spPr>
-        <p:txBody>
-          <a:bodyPr wrap="square" lIns="0" tIns="0" rIns="0" bIns="0" rtlCol="0" anchor="ctr"/>
+              <a:t>Learning Model · Trace Interruptions</a:t>
+            </a:r>
+            <a:endParaRPr lang="en-US" sz="1700" dirty="0"/>
+          </a:p>
+        </p:txBody>
+      </p:sp>
+      <p:sp>
+        <p:nvSpPr>
+          <p:cNvPr id="15" name="Text 13"/>
+          <p:cNvSpPr/>
+          <p:nvPr/>
+        </p:nvSpPr>
+        <p:spPr>
+          <a:xfrm>
+            <a:off x="1234440" y="1984248"/>
+            <a:ext cx="3767328" cy="941832"/>
+          </a:xfrm>
+          <a:prstGeom prst="rect">
+            <a:avLst/>
+          </a:prstGeom>
+          <a:noFill/>
+          <a:ln/>
+        </p:spPr>
+        <p:txBody>
+          <a:bodyPr wrap="square" lIns="0" tIns="0" rIns="0" bIns="0" rtlCol="0" anchor="t"/>
           <a:lstStyle/>
           <a:p>
             <a:pPr indent="0" marL="0">
@@ -3211,9 +3012,219 @@
                 <a:ea typeface="Calibri" pitchFamily="34" charset="-122"/>
                 <a:cs typeface="Calibri" pitchFamily="34" charset="-120"/>
               </a:rPr>
-              <a:t>Capture method is the product. Thought UI lives inside Think Aloud Protocol and Integrated Learning Environment tool surfaces — not a bolt-on form.</a:t>
+              <a:t>World-model style. Trace interruptions probe gaps mid-reasoning — and measure how interruption changes learning effectiveness.</a:t>
             </a:r>
             <a:endParaRPr lang="en-US" sz="1300" dirty="0"/>
+          </a:p>
+        </p:txBody>
+      </p:sp>
+      <p:sp>
+        <p:nvSpPr>
+          <p:cNvPr id="16" name="Shape 14"/>
+          <p:cNvSpPr/>
+          <p:nvPr/>
+        </p:nvSpPr>
+        <p:spPr>
+          <a:xfrm>
+            <a:off x="411480" y="3291840"/>
+            <a:ext cx="2336292" cy="1325880"/>
+          </a:xfrm>
+          <a:prstGeom prst="roundRect">
+            <a:avLst>
+              <a:gd name="adj" fmla="val 5517"/>
+            </a:avLst>
+          </a:prstGeom>
+          <a:solidFill>
+            <a:srgbClr val="181C26"/>
+          </a:solidFill>
+          <a:ln w="12700">
+            <a:solidFill>
+              <a:srgbClr val="2A3142"/>
+            </a:solidFill>
+            <a:prstDash val="solid"/>
+          </a:ln>
+        </p:spPr>
+      </p:sp>
+      <p:sp>
+        <p:nvSpPr>
+          <p:cNvPr id="17" name="Text 15"/>
+          <p:cNvSpPr/>
+          <p:nvPr/>
+        </p:nvSpPr>
+        <p:spPr>
+          <a:xfrm>
+            <a:off x="576072" y="3493008"/>
+            <a:ext cx="2007108" cy="274320"/>
+          </a:xfrm>
+          <a:prstGeom prst="rect">
+            <a:avLst/>
+          </a:prstGeom>
+          <a:noFill/>
+          <a:ln/>
+        </p:spPr>
+        <p:txBody>
+          <a:bodyPr wrap="square" lIns="0" tIns="0" rIns="0" bIns="0" rtlCol="0" anchor="ctr"/>
+          <a:lstStyle/>
+          <a:p>
+            <a:pPr indent="0" marL="0">
+              <a:buNone/>
+            </a:pPr>
+            <a:r>
+              <a:rPr lang="en-US" sz="1000" b="1" spc="80" kern="0" dirty="0">
+                <a:solidFill>
+                  <a:srgbClr val="E8B86D"/>
+                </a:solidFill>
+                <a:latin typeface="Consolas" pitchFamily="34" charset="0"/>
+                <a:ea typeface="Consolas" pitchFamily="34" charset="-122"/>
+                <a:cs typeface="Consolas" pitchFamily="34" charset="-120"/>
+              </a:rPr>
+              <a:t>PROBE GAPS</a:t>
+            </a:r>
+            <a:endParaRPr lang="en-US" sz="1000" dirty="0"/>
+          </a:p>
+        </p:txBody>
+      </p:sp>
+      <p:sp>
+        <p:nvSpPr>
+          <p:cNvPr id="18" name="Text 16"/>
+          <p:cNvSpPr/>
+          <p:nvPr/>
+        </p:nvSpPr>
+        <p:spPr>
+          <a:xfrm>
+            <a:off x="576072" y="3822192"/>
+            <a:ext cx="2007108" cy="640080"/>
+          </a:xfrm>
+          <a:prstGeom prst="rect">
+            <a:avLst/>
+          </a:prstGeom>
+          <a:noFill/>
+          <a:ln/>
+        </p:spPr>
+        <p:txBody>
+          <a:bodyPr wrap="square" lIns="0" tIns="0" rIns="0" bIns="0" rtlCol="0" anchor="ctr"/>
+          <a:lstStyle/>
+          <a:p>
+            <a:pPr indent="0" marL="0">
+              <a:buNone/>
+            </a:pPr>
+            <a:r>
+              <a:rPr lang="en-US" sz="1200" dirty="0">
+                <a:solidFill>
+                  <a:srgbClr val="C8D4F0"/>
+                </a:solidFill>
+                <a:latin typeface="Calibri" pitchFamily="34" charset="0"/>
+                <a:ea typeface="Calibri" pitchFamily="34" charset="-122"/>
+                <a:cs typeface="Calibri" pitchFamily="34" charset="-120"/>
+              </a:rPr>
+              <a:t>Interrupt at decision points to surface missing knowledge while reasoning is still live.</a:t>
+            </a:r>
+            <a:endParaRPr lang="en-US" sz="1200" dirty="0"/>
+          </a:p>
+        </p:txBody>
+      </p:sp>
+      <p:sp>
+        <p:nvSpPr>
+          <p:cNvPr id="19" name="Shape 17"/>
+          <p:cNvSpPr/>
+          <p:nvPr/>
+        </p:nvSpPr>
+        <p:spPr>
+          <a:xfrm>
+            <a:off x="2894076" y="3291840"/>
+            <a:ext cx="2336292" cy="1325880"/>
+          </a:xfrm>
+          <a:prstGeom prst="roundRect">
+            <a:avLst>
+              <a:gd name="adj" fmla="val 5517"/>
+            </a:avLst>
+          </a:prstGeom>
+          <a:solidFill>
+            <a:srgbClr val="181C26"/>
+          </a:solidFill>
+          <a:ln w="12700">
+            <a:solidFill>
+              <a:srgbClr val="2A3142"/>
+            </a:solidFill>
+            <a:prstDash val="solid"/>
+          </a:ln>
+        </p:spPr>
+      </p:sp>
+      <p:sp>
+        <p:nvSpPr>
+          <p:cNvPr id="20" name="Text 18"/>
+          <p:cNvSpPr/>
+          <p:nvPr/>
+        </p:nvSpPr>
+        <p:spPr>
+          <a:xfrm>
+            <a:off x="3058668" y="3493008"/>
+            <a:ext cx="2007108" cy="274320"/>
+          </a:xfrm>
+          <a:prstGeom prst="rect">
+            <a:avLst/>
+          </a:prstGeom>
+          <a:noFill/>
+          <a:ln/>
+        </p:spPr>
+        <p:txBody>
+          <a:bodyPr wrap="square" lIns="0" tIns="0" rIns="0" bIns="0" rtlCol="0" anchor="ctr"/>
+          <a:lstStyle/>
+          <a:p>
+            <a:pPr indent="0" marL="0">
+              <a:buNone/>
+            </a:pPr>
+            <a:r>
+              <a:rPr lang="en-US" sz="1000" b="1" spc="80" kern="0" dirty="0">
+                <a:solidFill>
+                  <a:srgbClr val="E8B86D"/>
+                </a:solidFill>
+                <a:latin typeface="Consolas" pitchFamily="34" charset="0"/>
+                <a:ea typeface="Consolas" pitchFamily="34" charset="-122"/>
+                <a:cs typeface="Consolas" pitchFamily="34" charset="-120"/>
+              </a:rPr>
+              <a:t>MEASURE EFFECT</a:t>
+            </a:r>
+            <a:endParaRPr lang="en-US" sz="1000" dirty="0"/>
+          </a:p>
+        </p:txBody>
+      </p:sp>
+      <p:sp>
+        <p:nvSpPr>
+          <p:cNvPr id="21" name="Text 19"/>
+          <p:cNvSpPr/>
+          <p:nvPr/>
+        </p:nvSpPr>
+        <p:spPr>
+          <a:xfrm>
+            <a:off x="3058668" y="3822192"/>
+            <a:ext cx="2007108" cy="640080"/>
+          </a:xfrm>
+          <a:prstGeom prst="rect">
+            <a:avLst/>
+          </a:prstGeom>
+          <a:noFill/>
+          <a:ln/>
+        </p:spPr>
+        <p:txBody>
+          <a:bodyPr wrap="square" lIns="0" tIns="0" rIns="0" bIns="0" rtlCol="0" anchor="ctr"/>
+          <a:lstStyle/>
+          <a:p>
+            <a:pPr indent="0" marL="0">
+              <a:buNone/>
+            </a:pPr>
+            <a:r>
+              <a:rPr lang="en-US" sz="1200" dirty="0">
+                <a:solidFill>
+                  <a:srgbClr val="C8D4F0"/>
+                </a:solidFill>
+                <a:latin typeface="Calibri" pitchFamily="34" charset="0"/>
+                <a:ea typeface="Calibri" pitchFamily="34" charset="-122"/>
+                <a:cs typeface="Calibri" pitchFamily="34" charset="-120"/>
+              </a:rPr>
+              <a:t>Track how interruptions shift learning effectiveness — not just whether the final answer was right.</a:t>
+            </a:r>
+            <a:endParaRPr lang="en-US" sz="1200" dirty="0"/>
           </a:p>
         </p:txBody>
       </p:sp>
@@ -3300,7 +3311,7 @@
                 <a:ea typeface="Consolas" pitchFamily="34" charset="-122"/>
                 <a:cs typeface="Consolas" pitchFamily="34" charset="-120"/>
               </a:rPr>
-              <a:t>04  ·  HOW THEY'RE USED</a:t>
+              <a:t>04  ·  PRODUCTIZED</a:t>
             </a:r>
             <a:endParaRPr lang="en-US" sz="1000" dirty="0"/>
           </a:p>
@@ -3339,7 +3350,7 @@
                 <a:ea typeface="Consolas" pitchFamily="34" charset="-122"/>
                 <a:cs typeface="Consolas" pitchFamily="34" charset="-120"/>
               </a:rPr>
-              <a:t>04 / 04</a:t>
+              <a:t>04 / 05</a:t>
             </a:r>
             <a:endParaRPr lang="en-US" sz="1000" dirty="0"/>
           </a:p>
@@ -3354,7 +3365,7 @@
         <p:spPr>
           <a:xfrm>
             <a:off x="411480" y="566928"/>
-            <a:ext cx="4818888" cy="502920"/>
+            <a:ext cx="4818888" cy="658368"/>
           </a:xfrm>
           <a:prstGeom prst="rect">
             <a:avLst/>
@@ -3378,7 +3389,24 @@
                 <a:ea typeface="Calibri" pitchFamily="34" charset="-122"/>
                 <a:cs typeface="Calibri" pitchFamily="34" charset="-120"/>
               </a:rPr>
-              <a:t>Integration surfaces.</a:t>
+              <a:t>Model surfaces in</a:t>
+            </a:r>
+            <a:endParaRPr lang="en-US" sz="2800" dirty="0"/>
+          </a:p>
+          <a:p>
+            <a:pPr indent="0" marL="0">
+              <a:buNone/>
+            </a:pPr>
+            <a:r>
+              <a:rPr lang="en-US" sz="2800" b="1" dirty="0">
+                <a:solidFill>
+                  <a:srgbClr val="FFFFFF"/>
+                </a:solidFill>
+                <a:latin typeface="Calibri" pitchFamily="34" charset="0"/>
+                <a:ea typeface="Calibri" pitchFamily="34" charset="-122"/>
+                <a:cs typeface="Calibri" pitchFamily="34" charset="-120"/>
+              </a:rPr>
+              <a:t>two product primitives.</a:t>
             </a:r>
             <a:endParaRPr lang="en-US" sz="2800" dirty="0"/>
           </a:p>
@@ -3490,7 +3518,7 @@
                 <a:ea typeface="Consolas" pitchFamily="34" charset="-122"/>
                 <a:cs typeface="Consolas" pitchFamily="34" charset="-120"/>
               </a:rPr>
-              <a:t>Integration map</a:t>
+              <a:t>UI / interaction model</a:t>
             </a:r>
             <a:endParaRPr lang="en-US" sz="1100" dirty="0"/>
           </a:p>
@@ -3543,12 +3571,12 @@
         </p:nvSpPr>
         <p:spPr>
           <a:xfrm>
-            <a:off x="411480" y="1280160"/>
-            <a:ext cx="2336292" cy="1024128"/>
+            <a:off x="411480" y="1417320"/>
+            <a:ext cx="4818888" cy="1554480"/>
           </a:xfrm>
           <a:prstGeom prst="roundRect">
             <a:avLst>
-              <a:gd name="adj" fmla="val 7143"/>
+              <a:gd name="adj" fmla="val 4706"/>
             </a:avLst>
           </a:prstGeom>
           <a:solidFill>
@@ -3570,8 +3598,8 @@
         </p:nvSpPr>
         <p:spPr>
           <a:xfrm>
-            <a:off x="557784" y="1444752"/>
-            <a:ext cx="2043684" cy="274320"/>
+            <a:off x="612648" y="1554480"/>
+            <a:ext cx="4416552" cy="219456"/>
           </a:xfrm>
           <a:prstGeom prst="rect">
             <a:avLst/>
@@ -3587,7 +3615,46 @@
               <a:buNone/>
             </a:pPr>
             <a:r>
-              <a:rPr lang="en-US" sz="1400" b="1" dirty="0">
+              <a:rPr lang="en-US" sz="1000" b="1" spc="100" kern="0" dirty="0">
+                <a:solidFill>
+                  <a:srgbClr val="7C9CFF"/>
+                </a:solidFill>
+                <a:latin typeface="Consolas" pitchFamily="34" charset="0"/>
+                <a:ea typeface="Consolas" pitchFamily="34" charset="-122"/>
+                <a:cs typeface="Consolas" pitchFamily="34" charset="-120"/>
+              </a:rPr>
+              <a:t>PROOF OF WORK</a:t>
+            </a:r>
+            <a:endParaRPr lang="en-US" sz="1000" dirty="0"/>
+          </a:p>
+        </p:txBody>
+      </p:sp>
+      <p:sp>
+        <p:nvSpPr>
+          <p:cNvPr id="13" name="Text 11"/>
+          <p:cNvSpPr/>
+          <p:nvPr/>
+        </p:nvSpPr>
+        <p:spPr>
+          <a:xfrm>
+            <a:off x="612648" y="1828800"/>
+            <a:ext cx="4416552" cy="320040"/>
+          </a:xfrm>
+          <a:prstGeom prst="rect">
+            <a:avLst/>
+          </a:prstGeom>
+          <a:noFill/>
+          <a:ln/>
+        </p:spPr>
+        <p:txBody>
+          <a:bodyPr wrap="square" lIns="0" tIns="0" rIns="0" bIns="0" rtlCol="0" anchor="ctr"/>
+          <a:lstStyle/>
+          <a:p>
+            <a:pPr indent="0" marL="0">
+              <a:buNone/>
+            </a:pPr>
+            <a:r>
+              <a:rPr lang="en-US" sz="1800" b="1" dirty="0">
                 <a:solidFill>
                   <a:srgbClr val="FFFFFF"/>
                 </a:solidFill>
@@ -3595,22 +3662,22 @@
                 <a:ea typeface="Calibri" pitchFamily="34" charset="-122"/>
                 <a:cs typeface="Calibri" pitchFamily="34" charset="-120"/>
               </a:rPr>
-              <a:t>PoW API gates</a:t>
-            </a:r>
-            <a:endParaRPr lang="en-US" sz="1400" dirty="0"/>
-          </a:p>
-        </p:txBody>
-      </p:sp>
-      <p:sp>
-        <p:nvSpPr>
-          <p:cNvPr id="13" name="Text 11"/>
-          <p:cNvSpPr/>
-          <p:nvPr/>
-        </p:nvSpPr>
-        <p:spPr>
-          <a:xfrm>
-            <a:off x="557784" y="1755648"/>
-            <a:ext cx="2043684" cy="438912"/>
+              <a:t>Submit–Stash interaction</a:t>
+            </a:r>
+            <a:endParaRPr lang="en-US" sz="1800" dirty="0"/>
+          </a:p>
+        </p:txBody>
+      </p:sp>
+      <p:sp>
+        <p:nvSpPr>
+          <p:cNvPr id="14" name="Text 12"/>
+          <p:cNvSpPr/>
+          <p:nvPr/>
+        </p:nvSpPr>
+        <p:spPr>
+          <a:xfrm>
+            <a:off x="612648" y="2212848"/>
+            <a:ext cx="4416552" cy="548640"/>
           </a:xfrm>
           <a:prstGeom prst="rect">
             <a:avLst/>
@@ -3626,7 +3693,7 @@
               <a:buNone/>
             </a:pPr>
             <a:r>
-              <a:rPr lang="en-US" sz="1200" dirty="0">
+              <a:rPr lang="en-US" sz="1300" dirty="0">
                 <a:solidFill>
                   <a:srgbClr val="8B93A7"/>
                 </a:solidFill>
@@ -3634,26 +3701,26 @@
                 <a:ea typeface="Calibri" pitchFamily="34" charset="-122"/>
                 <a:cs typeface="Calibri" pitchFamily="34" charset="-120"/>
               </a:rPr>
-              <a:t>Embed score + submit/stash into hiring, cert, or CI pipelines.</a:t>
-            </a:r>
-            <a:endParaRPr lang="en-US" sz="1200" dirty="0"/>
-          </a:p>
-        </p:txBody>
-      </p:sp>
-      <p:sp>
-        <p:nvSpPr>
-          <p:cNvPr id="14" name="Shape 12"/>
-          <p:cNvSpPr/>
-          <p:nvPr/>
-        </p:nvSpPr>
-        <p:spPr>
-          <a:xfrm>
-            <a:off x="2894076" y="1280160"/>
-            <a:ext cx="2336292" cy="1024128"/>
+              <a:t>Stream answers continuously. Learner (or agent) signals submit or stash — scoring attaches to intent, not just final paste.</a:t>
+            </a:r>
+            <a:endParaRPr lang="en-US" sz="1300" dirty="0"/>
+          </a:p>
+        </p:txBody>
+      </p:sp>
+      <p:sp>
+        <p:nvSpPr>
+          <p:cNvPr id="15" name="Shape 13"/>
+          <p:cNvSpPr/>
+          <p:nvPr/>
+        </p:nvSpPr>
+        <p:spPr>
+          <a:xfrm>
+            <a:off x="411480" y="3154680"/>
+            <a:ext cx="4818888" cy="1554480"/>
           </a:xfrm>
           <a:prstGeom prst="roundRect">
             <a:avLst>
-              <a:gd name="adj" fmla="val 7143"/>
+              <a:gd name="adj" fmla="val 4706"/>
             </a:avLst>
           </a:prstGeom>
           <a:solidFill>
@@ -3669,14 +3736,14 @@
       </p:sp>
       <p:sp>
         <p:nvSpPr>
-          <p:cNvPr id="15" name="Text 13"/>
-          <p:cNvSpPr/>
-          <p:nvPr/>
-        </p:nvSpPr>
-        <p:spPr>
-          <a:xfrm>
-            <a:off x="3040380" y="1444752"/>
-            <a:ext cx="2043684" cy="274320"/>
+          <p:cNvPr id="16" name="Text 14"/>
+          <p:cNvSpPr/>
+          <p:nvPr/>
+        </p:nvSpPr>
+        <p:spPr>
+          <a:xfrm>
+            <a:off x="612648" y="3291840"/>
+            <a:ext cx="4416552" cy="219456"/>
           </a:xfrm>
           <a:prstGeom prst="rect">
             <a:avLst/>
@@ -3692,7 +3759,46 @@
               <a:buNone/>
             </a:pPr>
             <a:r>
-              <a:rPr lang="en-US" sz="1400" b="1" dirty="0">
+              <a:rPr lang="en-US" sz="1000" b="1" spc="100" kern="0" dirty="0">
+                <a:solidFill>
+                  <a:srgbClr val="6BCB9A"/>
+                </a:solidFill>
+                <a:latin typeface="Consolas" pitchFamily="34" charset="0"/>
+                <a:ea typeface="Consolas" pitchFamily="34" charset="-122"/>
+                <a:cs typeface="Consolas" pitchFamily="34" charset="-120"/>
+              </a:rPr>
+              <a:t>SELECTIVE THOUGHT INTERFACE</a:t>
+            </a:r>
+            <a:endParaRPr lang="en-US" sz="1000" dirty="0"/>
+          </a:p>
+        </p:txBody>
+      </p:sp>
+      <p:sp>
+        <p:nvSpPr>
+          <p:cNvPr id="17" name="Text 15"/>
+          <p:cNvSpPr/>
+          <p:nvPr/>
+        </p:nvSpPr>
+        <p:spPr>
+          <a:xfrm>
+            <a:off x="612648" y="3566160"/>
+            <a:ext cx="4416552" cy="320040"/>
+          </a:xfrm>
+          <a:prstGeom prst="rect">
+            <a:avLst/>
+          </a:prstGeom>
+          <a:noFill/>
+          <a:ln/>
+        </p:spPr>
+        <p:txBody>
+          <a:bodyPr wrap="square" lIns="0" tIns="0" rIns="0" bIns="0" rtlCol="0" anchor="ctr"/>
+          <a:lstStyle/>
+          <a:p>
+            <a:pPr indent="0" marL="0">
+              <a:buNone/>
+            </a:pPr>
+            <a:r>
+              <a:rPr lang="en-US" sz="1800" b="1" dirty="0">
                 <a:solidFill>
                   <a:srgbClr val="FFFFFF"/>
                 </a:solidFill>
@@ -3700,22 +3806,22 @@
                 <a:ea typeface="Calibri" pitchFamily="34" charset="-122"/>
                 <a:cs typeface="Calibri" pitchFamily="34" charset="-120"/>
               </a:rPr>
-              <a:t>TAP sessions</a:t>
-            </a:r>
-            <a:endParaRPr lang="en-US" sz="1400" dirty="0"/>
-          </a:p>
-        </p:txBody>
-      </p:sp>
-      <p:sp>
-        <p:nvSpPr>
-          <p:cNvPr id="16" name="Text 14"/>
-          <p:cNvSpPr/>
-          <p:nvPr/>
-        </p:nvSpPr>
-        <p:spPr>
-          <a:xfrm>
-            <a:off x="3040380" y="1755648"/>
-            <a:ext cx="2043684" cy="438912"/>
+              <a:t>UI inside TAP &amp; ILE tools</a:t>
+            </a:r>
+            <a:endParaRPr lang="en-US" sz="1800" dirty="0"/>
+          </a:p>
+        </p:txBody>
+      </p:sp>
+      <p:sp>
+        <p:nvSpPr>
+          <p:cNvPr id="18" name="Text 16"/>
+          <p:cNvSpPr/>
+          <p:nvPr/>
+        </p:nvSpPr>
+        <p:spPr>
+          <a:xfrm>
+            <a:off x="612648" y="3950208"/>
+            <a:ext cx="4416552" cy="594360"/>
           </a:xfrm>
           <a:prstGeom prst="rect">
             <a:avLst/>
@@ -3731,7 +3837,7 @@
               <a:buNone/>
             </a:pPr>
             <a:r>
-              <a:rPr lang="en-US" sz="1200" dirty="0">
+              <a:rPr lang="en-US" sz="1300" dirty="0">
                 <a:solidFill>
                   <a:srgbClr val="8B93A7"/>
                 </a:solidFill>
@@ -3739,26 +3845,344 @@
                 <a:ea typeface="Calibri" pitchFamily="34" charset="-122"/>
                 <a:cs typeface="Calibri" pitchFamily="34" charset="-120"/>
               </a:rPr>
-              <a:t>Shareable think-aloud links for live human verification.</a:t>
-            </a:r>
-            <a:endParaRPr lang="en-US" sz="1200" dirty="0"/>
-          </a:p>
-        </p:txBody>
-      </p:sp>
-      <p:sp>
-        <p:nvSpPr>
-          <p:cNvPr id="17" name="Shape 15"/>
-          <p:cNvSpPr/>
-          <p:nvPr/>
-        </p:nvSpPr>
-        <p:spPr>
-          <a:xfrm>
-            <a:off x="411480" y="2423160"/>
-            <a:ext cx="2336292" cy="1024128"/>
+              <a:t>Capture method is the product. Thought UI lives inside Think Aloud Protocol and Integrated Learning Environment tool surfaces — not a bolt-on form.</a:t>
+            </a:r>
+            <a:endParaRPr lang="en-US" sz="1300" dirty="0"/>
+          </a:p>
+        </p:txBody>
+      </p:sp>
+    </p:spTree>
+  </p:cSld>
+  <p:clrMapOvr>
+    <a:masterClrMapping/>
+  </p:clrMapOvr>
+</p:sld>
+</file>
+
+<file path=ppt/slides/slide5.xml><?xml version="1.0" encoding="utf-8"?>
+<p:sld xmlns:a="http://schemas.openxmlformats.org/drawingml/2006/main" xmlns:r="http://schemas.openxmlformats.org/officeDocument/2006/relationships" xmlns:p="http://schemas.openxmlformats.org/presentationml/2006/main">
+  <p:cSld name="Slide 5">
+    <p:spTree>
+      <p:nvGrpSpPr>
+        <p:cNvPr id="1" name=""/>
+        <p:cNvGrpSpPr/>
+        <p:nvPr/>
+      </p:nvGrpSpPr>
+      <p:grpSpPr>
+        <a:xfrm>
+          <a:off x="0" y="0"/>
+          <a:ext cx="0" cy="0"/>
+          <a:chOff x="0" y="0"/>
+          <a:chExt cx="0" cy="0"/>
+        </a:xfrm>
+      </p:grpSpPr>
+      <p:sp>
+        <p:nvSpPr>
+          <p:cNvPr id="2" name="Shape 0"/>
+          <p:cNvSpPr/>
+          <p:nvPr/>
+        </p:nvSpPr>
+        <p:spPr>
+          <a:xfrm>
+            <a:off x="0" y="0"/>
+            <a:ext cx="9144000" cy="5143500"/>
+          </a:xfrm>
+          <a:prstGeom prst="rect">
+            <a:avLst/>
+          </a:prstGeom>
+          <a:solidFill>
+            <a:srgbClr val="0B0D12"/>
+          </a:solidFill>
+          <a:ln w="12700">
+            <a:solidFill>
+              <a:srgbClr val="0B0D12"/>
+            </a:solidFill>
+            <a:prstDash val="solid"/>
+          </a:ln>
+        </p:spPr>
+      </p:sp>
+      <p:sp>
+        <p:nvSpPr>
+          <p:cNvPr id="3" name="Text 1"/>
+          <p:cNvSpPr/>
+          <p:nvPr/>
+        </p:nvSpPr>
+        <p:spPr>
+          <a:xfrm>
+            <a:off x="411480" y="256032"/>
+            <a:ext cx="4818888" cy="256032"/>
+          </a:xfrm>
+          <a:prstGeom prst="rect">
+            <a:avLst/>
+          </a:prstGeom>
+          <a:noFill/>
+          <a:ln/>
+        </p:spPr>
+        <p:txBody>
+          <a:bodyPr wrap="square" lIns="0" tIns="0" rIns="0" bIns="0" rtlCol="0" anchor="ctr"/>
+          <a:lstStyle/>
+          <a:p>
+            <a:pPr indent="0" marL="0">
+              <a:buNone/>
+            </a:pPr>
+            <a:r>
+              <a:rPr lang="en-US" sz="1000" b="1" spc="150" kern="0" dirty="0">
+                <a:solidFill>
+                  <a:srgbClr val="7C9CFF"/>
+                </a:solidFill>
+                <a:latin typeface="Consolas" pitchFamily="34" charset="0"/>
+                <a:ea typeface="Consolas" pitchFamily="34" charset="-122"/>
+                <a:cs typeface="Consolas" pitchFamily="34" charset="-120"/>
+              </a:rPr>
+              <a:t>05  ·  HOW THEY'RE USED</a:t>
+            </a:r>
+            <a:endParaRPr lang="en-US" sz="1000" dirty="0"/>
+          </a:p>
+        </p:txBody>
+      </p:sp>
+      <p:sp>
+        <p:nvSpPr>
+          <p:cNvPr id="4" name="Text 2"/>
+          <p:cNvSpPr/>
+          <p:nvPr/>
+        </p:nvSpPr>
+        <p:spPr>
+          <a:xfrm>
+            <a:off x="5486400" y="256032"/>
+            <a:ext cx="3246120" cy="256032"/>
+          </a:xfrm>
+          <a:prstGeom prst="rect">
+            <a:avLst/>
+          </a:prstGeom>
+          <a:noFill/>
+          <a:ln/>
+        </p:spPr>
+        <p:txBody>
+          <a:bodyPr wrap="square" lIns="0" tIns="0" rIns="0" bIns="0" rtlCol="0" anchor="ctr"/>
+          <a:lstStyle/>
+          <a:p>
+            <a:pPr algn="r" indent="0" marL="0">
+              <a:buNone/>
+            </a:pPr>
+            <a:r>
+              <a:rPr lang="en-US" sz="1000" dirty="0">
+                <a:solidFill>
+                  <a:srgbClr val="5C657A"/>
+                </a:solidFill>
+                <a:latin typeface="Consolas" pitchFamily="34" charset="0"/>
+                <a:ea typeface="Consolas" pitchFamily="34" charset="-122"/>
+                <a:cs typeface="Consolas" pitchFamily="34" charset="-120"/>
+              </a:rPr>
+              <a:t>05 / 05</a:t>
+            </a:r>
+            <a:endParaRPr lang="en-US" sz="1000" dirty="0"/>
+          </a:p>
+        </p:txBody>
+      </p:sp>
+      <p:sp>
+        <p:nvSpPr>
+          <p:cNvPr id="5" name="Text 3"/>
+          <p:cNvSpPr/>
+          <p:nvPr/>
+        </p:nvSpPr>
+        <p:spPr>
+          <a:xfrm>
+            <a:off x="411480" y="566928"/>
+            <a:ext cx="4818888" cy="457200"/>
+          </a:xfrm>
+          <a:prstGeom prst="rect">
+            <a:avLst/>
+          </a:prstGeom>
+          <a:noFill/>
+          <a:ln/>
+        </p:spPr>
+        <p:txBody>
+          <a:bodyPr wrap="square" lIns="0" tIns="0" rIns="0" bIns="0" rtlCol="0" anchor="t"/>
+          <a:lstStyle/>
+          <a:p>
+            <a:pPr indent="0" marL="0">
+              <a:buNone/>
+            </a:pPr>
+            <a:r>
+              <a:rPr lang="en-US" sz="2800" b="1" dirty="0">
+                <a:solidFill>
+                  <a:srgbClr val="FFFFFF"/>
+                </a:solidFill>
+                <a:latin typeface="Calibri" pitchFamily="34" charset="0"/>
+                <a:ea typeface="Calibri" pitchFamily="34" charset="-122"/>
+                <a:cs typeface="Calibri" pitchFamily="34" charset="-120"/>
+              </a:rPr>
+              <a:t>What each product is for.</a:t>
+            </a:r>
+            <a:endParaRPr lang="en-US" sz="2800" dirty="0"/>
+          </a:p>
+        </p:txBody>
+      </p:sp>
+      <p:sp>
+        <p:nvSpPr>
+          <p:cNvPr id="6" name="Shape 4"/>
+          <p:cNvSpPr/>
+          <p:nvPr/>
+        </p:nvSpPr>
+        <p:spPr>
+          <a:xfrm>
+            <a:off x="5486400" y="822960"/>
+            <a:ext cx="3246120" cy="4000500"/>
           </a:xfrm>
           <a:prstGeom prst="roundRect">
             <a:avLst>
-              <a:gd name="adj" fmla="val 7143"/>
+              <a:gd name="adj" fmla="val 2817"/>
+            </a:avLst>
+          </a:prstGeom>
+          <a:solidFill>
+            <a:srgbClr val="151922"/>
+          </a:solidFill>
+          <a:ln w="15875">
+            <a:solidFill>
+              <a:srgbClr val="3A4258"/>
+            </a:solidFill>
+            <a:prstDash val="dash"/>
+          </a:ln>
+        </p:spPr>
+      </p:sp>
+      <p:sp>
+        <p:nvSpPr>
+          <p:cNvPr id="7" name="Shape 5"/>
+          <p:cNvSpPr/>
+          <p:nvPr/>
+        </p:nvSpPr>
+        <p:spPr>
+          <a:xfrm>
+            <a:off x="6789420" y="2823210"/>
+            <a:ext cx="640080" cy="0"/>
+          </a:xfrm>
+          <a:prstGeom prst="line">
+            <a:avLst/>
+          </a:prstGeom>
+          <a:noFill/>
+          <a:ln w="15875">
+            <a:solidFill>
+              <a:srgbClr val="5C657A"/>
+            </a:solidFill>
+            <a:prstDash val="solid"/>
+          </a:ln>
+        </p:spPr>
+      </p:sp>
+      <p:sp>
+        <p:nvSpPr>
+          <p:cNvPr id="8" name="Shape 6"/>
+          <p:cNvSpPr/>
+          <p:nvPr/>
+        </p:nvSpPr>
+        <p:spPr>
+          <a:xfrm>
+            <a:off x="7109460" y="2503170"/>
+            <a:ext cx="0" cy="640080"/>
+          </a:xfrm>
+          <a:prstGeom prst="line">
+            <a:avLst/>
+          </a:prstGeom>
+          <a:noFill/>
+          <a:ln w="15875">
+            <a:solidFill>
+              <a:srgbClr val="5C657A"/>
+            </a:solidFill>
+            <a:prstDash val="solid"/>
+          </a:ln>
+        </p:spPr>
+      </p:sp>
+      <p:sp>
+        <p:nvSpPr>
+          <p:cNvPr id="9" name="Text 7"/>
+          <p:cNvSpPr/>
+          <p:nvPr/>
+        </p:nvSpPr>
+        <p:spPr>
+          <a:xfrm>
+            <a:off x="5669280" y="3234690"/>
+            <a:ext cx="2880360" cy="320040"/>
+          </a:xfrm>
+          <a:prstGeom prst="rect">
+            <a:avLst/>
+          </a:prstGeom>
+          <a:noFill/>
+          <a:ln/>
+        </p:spPr>
+        <p:txBody>
+          <a:bodyPr wrap="square" lIns="0" tIns="0" rIns="0" bIns="0" rtlCol="0" anchor="ctr"/>
+          <a:lstStyle/>
+          <a:p>
+            <a:pPr algn="ctr" indent="0" marL="0">
+              <a:buNone/>
+            </a:pPr>
+            <a:r>
+              <a:rPr lang="en-US" sz="1100" dirty="0">
+                <a:solidFill>
+                  <a:srgbClr val="5C657A"/>
+                </a:solidFill>
+                <a:latin typeface="Consolas" pitchFamily="34" charset="0"/>
+                <a:ea typeface="Consolas" pitchFamily="34" charset="-122"/>
+                <a:cs typeface="Consolas" pitchFamily="34" charset="-120"/>
+              </a:rPr>
+              <a:t>Integration map</a:t>
+            </a:r>
+            <a:endParaRPr lang="en-US" sz="1100" dirty="0"/>
+          </a:p>
+        </p:txBody>
+      </p:sp>
+      <p:sp>
+        <p:nvSpPr>
+          <p:cNvPr id="10" name="Text 8"/>
+          <p:cNvSpPr/>
+          <p:nvPr/>
+        </p:nvSpPr>
+        <p:spPr>
+          <a:xfrm>
+            <a:off x="5669280" y="1005840"/>
+            <a:ext cx="2880360" cy="256032"/>
+          </a:xfrm>
+          <a:prstGeom prst="rect">
+            <a:avLst/>
+          </a:prstGeom>
+          <a:noFill/>
+          <a:ln/>
+        </p:spPr>
+        <p:txBody>
+          <a:bodyPr wrap="square" lIns="0" tIns="0" rIns="0" bIns="0" rtlCol="0" anchor="ctr"/>
+          <a:lstStyle/>
+          <a:p>
+            <a:pPr algn="ctr" indent="0" marL="0">
+              <a:buNone/>
+            </a:pPr>
+            <a:r>
+              <a:rPr lang="en-US" sz="900" spc="200" kern="0" dirty="0">
+                <a:solidFill>
+                  <a:srgbClr val="5C657A"/>
+                </a:solidFill>
+                <a:latin typeface="Consolas" pitchFamily="34" charset="0"/>
+                <a:ea typeface="Consolas" pitchFamily="34" charset="-122"/>
+                <a:cs typeface="Consolas" pitchFamily="34" charset="-120"/>
+              </a:rPr>
+              <a:t>PLACEHOLDER</a:t>
+            </a:r>
+            <a:endParaRPr lang="en-US" sz="900" dirty="0"/>
+          </a:p>
+        </p:txBody>
+      </p:sp>
+      <p:sp>
+        <p:nvSpPr>
+          <p:cNvPr id="11" name="Shape 9"/>
+          <p:cNvSpPr/>
+          <p:nvPr/>
+        </p:nvSpPr>
+        <p:spPr>
+          <a:xfrm>
+            <a:off x="411480" y="1234440"/>
+            <a:ext cx="4818888" cy="1051560"/>
+          </a:xfrm>
+          <a:prstGeom prst="roundRect">
+            <a:avLst>
+              <a:gd name="adj" fmla="val 6957"/>
             </a:avLst>
           </a:prstGeom>
           <a:solidFill>
@@ -3774,14 +4198,39 @@
       </p:sp>
       <p:sp>
         <p:nvSpPr>
-          <p:cNvPr id="18" name="Text 16"/>
-          <p:cNvSpPr/>
-          <p:nvPr/>
-        </p:nvSpPr>
-        <p:spPr>
-          <a:xfrm>
-            <a:off x="557784" y="2587752"/>
-            <a:ext cx="2043684" cy="274320"/>
+          <p:cNvPr id="12" name="Shape 10"/>
+          <p:cNvSpPr/>
+          <p:nvPr/>
+        </p:nvSpPr>
+        <p:spPr>
+          <a:xfrm>
+            <a:off x="411480" y="1234440"/>
+            <a:ext cx="64008" cy="1051560"/>
+          </a:xfrm>
+          <a:prstGeom prst="rect">
+            <a:avLst/>
+          </a:prstGeom>
+          <a:solidFill>
+            <a:srgbClr val="7C9CFF"/>
+          </a:solidFill>
+          <a:ln w="12700">
+            <a:solidFill>
+              <a:srgbClr val="7C9CFF"/>
+            </a:solidFill>
+            <a:prstDash val="solid"/>
+          </a:ln>
+        </p:spPr>
+      </p:sp>
+      <p:sp>
+        <p:nvSpPr>
+          <p:cNvPr id="13" name="Text 11"/>
+          <p:cNvSpPr/>
+          <p:nvPr/>
+        </p:nvSpPr>
+        <p:spPr>
+          <a:xfrm>
+            <a:off x="612648" y="1362456"/>
+            <a:ext cx="640080" cy="795528"/>
           </a:xfrm>
           <a:prstGeom prst="rect">
             <a:avLst/>
@@ -3797,73 +4246,116 @@
               <a:buNone/>
             </a:pPr>
             <a:r>
-              <a:rPr lang="en-US" sz="1400" b="1" dirty="0">
-                <a:solidFill>
-                  <a:srgbClr val="FFFFFF"/>
+              <a:rPr lang="en-US" sz="1300" b="1" dirty="0">
+                <a:solidFill>
+                  <a:srgbClr val="7C9CFF"/>
+                </a:solidFill>
+                <a:latin typeface="Consolas" pitchFamily="34" charset="0"/>
+                <a:ea typeface="Consolas" pitchFamily="34" charset="-122"/>
+                <a:cs typeface="Consolas" pitchFamily="34" charset="-120"/>
+              </a:rPr>
+              <a:t>PoW</a:t>
+            </a:r>
+            <a:endParaRPr lang="en-US" sz="1300" dirty="0"/>
+          </a:p>
+        </p:txBody>
+      </p:sp>
+      <p:sp>
+        <p:nvSpPr>
+          <p:cNvPr id="14" name="Text 12"/>
+          <p:cNvSpPr/>
+          <p:nvPr/>
+        </p:nvSpPr>
+        <p:spPr>
+          <a:xfrm>
+            <a:off x="1325880" y="1344168"/>
+            <a:ext cx="3721608" cy="832104"/>
+          </a:xfrm>
+          <a:prstGeom prst="rect">
+            <a:avLst/>
+          </a:prstGeom>
+          <a:noFill/>
+          <a:ln/>
+        </p:spPr>
+        <p:txBody>
+          <a:bodyPr wrap="square" lIns="0" tIns="0" rIns="0" bIns="0" rtlCol="0" anchor="ctr"/>
+          <a:lstStyle/>
+          <a:p>
+            <a:pPr indent="0" marL="0">
+              <a:spcAft>
+                <a:spcPts val="300"/>
+              </a:spcAft>
+              <a:buNone/>
+            </a:pPr>
+            <a:r>
+              <a:rPr lang="en-US" sz="1200" dirty="0">
+                <a:solidFill>
+                  <a:srgbClr val="C8D4F0"/>
                 </a:solidFill>
                 <a:latin typeface="Calibri" pitchFamily="34" charset="0"/>
                 <a:ea typeface="Calibri" pitchFamily="34" charset="-122"/>
                 <a:cs typeface="Calibri" pitchFamily="34" charset="-120"/>
               </a:rPr>
-              <a:t>ILE practice</a:t>
-            </a:r>
-            <a:endParaRPr lang="en-US" sz="1400" dirty="0"/>
-          </a:p>
-        </p:txBody>
-      </p:sp>
-      <p:sp>
-        <p:nvSpPr>
-          <p:cNvPr id="19" name="Text 17"/>
-          <p:cNvSpPr/>
-          <p:nvPr/>
-        </p:nvSpPr>
-        <p:spPr>
-          <a:xfrm>
-            <a:off x="557784" y="2898648"/>
-            <a:ext cx="2043684" cy="438912"/>
-          </a:xfrm>
-          <a:prstGeom prst="rect">
-            <a:avLst/>
-          </a:prstGeom>
-          <a:noFill/>
-          <a:ln/>
-        </p:spPr>
-        <p:txBody>
-          <a:bodyPr wrap="square" lIns="0" tIns="0" rIns="0" bIns="0" rtlCol="0" anchor="ctr"/>
-          <a:lstStyle/>
+              <a:t>·  Screen hires on real work, not résumés</a:t>
+            </a:r>
+            <a:endParaRPr lang="en-US" sz="1200" dirty="0"/>
+          </a:p>
           <a:p>
             <a:pPr indent="0" marL="0">
+              <a:spcAft>
+                <a:spcPts val="300"/>
+              </a:spcAft>
               <a:buNone/>
             </a:pPr>
             <a:r>
               <a:rPr lang="en-US" sz="1200" dirty="0">
                 <a:solidFill>
-                  <a:srgbClr val="8B93A7"/>
+                  <a:srgbClr val="C8D4F0"/>
                 </a:solidFill>
                 <a:latin typeface="Calibri" pitchFamily="34" charset="0"/>
                 <a:ea typeface="Calibri" pitchFamily="34" charset="-122"/>
                 <a:cs typeface="Calibri" pitchFamily="34" charset="-120"/>
               </a:rPr>
-              <a:t>Coached scenarios as take-home / quiz replacements.</a:t>
+              <a:t>·  Gate certifications on proof, not quizzes</a:t>
             </a:r>
             <a:endParaRPr lang="en-US" sz="1200" dirty="0"/>
           </a:p>
-        </p:txBody>
-      </p:sp>
-      <p:sp>
-        <p:nvSpPr>
-          <p:cNvPr id="20" name="Shape 18"/>
-          <p:cNvSpPr/>
-          <p:nvPr/>
-        </p:nvSpPr>
-        <p:spPr>
-          <a:xfrm>
-            <a:off x="2894076" y="2423160"/>
-            <a:ext cx="2336292" cy="1024128"/>
+          <a:p>
+            <a:pPr indent="0" marL="0">
+              <a:spcAft>
+                <a:spcPts val="300"/>
+              </a:spcAft>
+              <a:buNone/>
+            </a:pPr>
+            <a:r>
+              <a:rPr lang="en-US" sz="1200" dirty="0">
+                <a:solidFill>
+                  <a:srgbClr val="C8D4F0"/>
+                </a:solidFill>
+                <a:latin typeface="Calibri" pitchFamily="34" charset="0"/>
+                <a:ea typeface="Calibri" pitchFamily="34" charset="-122"/>
+                <a:cs typeface="Calibri" pitchFamily="34" charset="-120"/>
+              </a:rPr>
+              <a:t>·  Stop weak agent or CI output before it ships</a:t>
+            </a:r>
+            <a:endParaRPr lang="en-US" sz="1200" dirty="0"/>
+          </a:p>
+        </p:txBody>
+      </p:sp>
+      <p:sp>
+        <p:nvSpPr>
+          <p:cNvPr id="15" name="Shape 13"/>
+          <p:cNvSpPr/>
+          <p:nvPr/>
+        </p:nvSpPr>
+        <p:spPr>
+          <a:xfrm>
+            <a:off x="411480" y="2395728"/>
+            <a:ext cx="4818888" cy="1051560"/>
           </a:xfrm>
           <a:prstGeom prst="roundRect">
             <a:avLst>
-              <a:gd name="adj" fmla="val 7143"/>
+              <a:gd name="adj" fmla="val 6957"/>
             </a:avLst>
           </a:prstGeom>
           <a:solidFill>
@@ -3879,14 +4371,39 @@
       </p:sp>
       <p:sp>
         <p:nvSpPr>
-          <p:cNvPr id="21" name="Text 19"/>
-          <p:cNvSpPr/>
-          <p:nvPr/>
-        </p:nvSpPr>
-        <p:spPr>
-          <a:xfrm>
-            <a:off x="3040380" y="2587752"/>
-            <a:ext cx="2043684" cy="274320"/>
+          <p:cNvPr id="16" name="Shape 14"/>
+          <p:cNvSpPr/>
+          <p:nvPr/>
+        </p:nvSpPr>
+        <p:spPr>
+          <a:xfrm>
+            <a:off x="411480" y="2395728"/>
+            <a:ext cx="64008" cy="1051560"/>
+          </a:xfrm>
+          <a:prstGeom prst="rect">
+            <a:avLst/>
+          </a:prstGeom>
+          <a:solidFill>
+            <a:srgbClr val="6BCB9A"/>
+          </a:solidFill>
+          <a:ln w="12700">
+            <a:solidFill>
+              <a:srgbClr val="6BCB9A"/>
+            </a:solidFill>
+            <a:prstDash val="solid"/>
+          </a:ln>
+        </p:spPr>
+      </p:sp>
+      <p:sp>
+        <p:nvSpPr>
+          <p:cNvPr id="17" name="Text 15"/>
+          <p:cNvSpPr/>
+          <p:nvPr/>
+        </p:nvSpPr>
+        <p:spPr>
+          <a:xfrm>
+            <a:off x="612648" y="2523744"/>
+            <a:ext cx="640080" cy="795528"/>
           </a:xfrm>
           <a:prstGeom prst="rect">
             <a:avLst/>
@@ -3902,73 +4419,116 @@
               <a:buNone/>
             </a:pPr>
             <a:r>
-              <a:rPr lang="en-US" sz="1400" b="1" dirty="0">
-                <a:solidFill>
-                  <a:srgbClr val="FFFFFF"/>
+              <a:rPr lang="en-US" sz="1300" b="1" dirty="0">
+                <a:solidFill>
+                  <a:srgbClr val="6BCB9A"/>
+                </a:solidFill>
+                <a:latin typeface="Consolas" pitchFamily="34" charset="0"/>
+                <a:ea typeface="Consolas" pitchFamily="34" charset="-122"/>
+                <a:cs typeface="Consolas" pitchFamily="34" charset="-120"/>
+              </a:rPr>
+              <a:t>TAP</a:t>
+            </a:r>
+            <a:endParaRPr lang="en-US" sz="1300" dirty="0"/>
+          </a:p>
+        </p:txBody>
+      </p:sp>
+      <p:sp>
+        <p:nvSpPr>
+          <p:cNvPr id="18" name="Text 16"/>
+          <p:cNvSpPr/>
+          <p:nvPr/>
+        </p:nvSpPr>
+        <p:spPr>
+          <a:xfrm>
+            <a:off x="1325880" y="2505456"/>
+            <a:ext cx="3721608" cy="832104"/>
+          </a:xfrm>
+          <a:prstGeom prst="rect">
+            <a:avLst/>
+          </a:prstGeom>
+          <a:noFill/>
+          <a:ln/>
+        </p:spPr>
+        <p:txBody>
+          <a:bodyPr wrap="square" lIns="0" tIns="0" rIns="0" bIns="0" rtlCol="0" anchor="ctr"/>
+          <a:lstStyle/>
+          <a:p>
+            <a:pPr indent="0" marL="0">
+              <a:spcAft>
+                <a:spcPts val="300"/>
+              </a:spcAft>
+              <a:buNone/>
+            </a:pPr>
+            <a:r>
+              <a:rPr lang="en-US" sz="1200" dirty="0">
+                <a:solidFill>
+                  <a:srgbClr val="C8D4F0"/>
                 </a:solidFill>
                 <a:latin typeface="Calibri" pitchFamily="34" charset="0"/>
                 <a:ea typeface="Calibri" pitchFamily="34" charset="-122"/>
                 <a:cs typeface="Calibri" pitchFamily="34" charset="-120"/>
               </a:rPr>
-              <a:t>LMS / courses</a:t>
-            </a:r>
-            <a:endParaRPr lang="en-US" sz="1400" dirty="0"/>
-          </a:p>
-        </p:txBody>
-      </p:sp>
-      <p:sp>
-        <p:nvSpPr>
-          <p:cNvPr id="22" name="Text 20"/>
-          <p:cNvSpPr/>
-          <p:nvPr/>
-        </p:nvSpPr>
-        <p:spPr>
-          <a:xfrm>
-            <a:off x="3040380" y="2898648"/>
-            <a:ext cx="2043684" cy="438912"/>
-          </a:xfrm>
-          <a:prstGeom prst="rect">
-            <a:avLst/>
-          </a:prstGeom>
-          <a:noFill/>
-          <a:ln/>
-        </p:spPr>
-        <p:txBody>
-          <a:bodyPr wrap="square" lIns="0" tIns="0" rIns="0" bIns="0" rtlCol="0" anchor="ctr"/>
-          <a:lstStyle/>
+              <a:t>·  Run live think-aloud interviews</a:t>
+            </a:r>
+            <a:endParaRPr lang="en-US" sz="1200" dirty="0"/>
+          </a:p>
           <a:p>
             <a:pPr indent="0" marL="0">
+              <a:spcAft>
+                <a:spcPts val="300"/>
+              </a:spcAft>
               <a:buNone/>
             </a:pPr>
             <a:r>
               <a:rPr lang="en-US" sz="1200" dirty="0">
                 <a:solidFill>
-                  <a:srgbClr val="8B93A7"/>
+                  <a:srgbClr val="C8D4F0"/>
                 </a:solidFill>
                 <a:latin typeface="Calibri" pitchFamily="34" charset="0"/>
                 <a:ea typeface="Calibri" pitchFamily="34" charset="-122"/>
                 <a:cs typeface="Calibri" pitchFamily="34" charset="-120"/>
               </a:rPr>
-              <a:t>Interruption + proximity scoring inside existing learning paths.</a:t>
+              <a:t>·  Capture how experts actually solve problems</a:t>
             </a:r>
             <a:endParaRPr lang="en-US" sz="1200" dirty="0"/>
           </a:p>
-        </p:txBody>
-      </p:sp>
-      <p:sp>
-        <p:nvSpPr>
-          <p:cNvPr id="23" name="Shape 21"/>
-          <p:cNvSpPr/>
-          <p:nvPr/>
-        </p:nvSpPr>
-        <p:spPr>
-          <a:xfrm>
-            <a:off x="411480" y="3566160"/>
-            <a:ext cx="2336292" cy="1024128"/>
+          <a:p>
+            <a:pPr indent="0" marL="0">
+              <a:spcAft>
+                <a:spcPts val="300"/>
+              </a:spcAft>
+              <a:buNone/>
+            </a:pPr>
+            <a:r>
+              <a:rPr lang="en-US" sz="1200" dirty="0">
+                <a:solidFill>
+                  <a:srgbClr val="C8D4F0"/>
+                </a:solidFill>
+                <a:latin typeface="Calibri" pitchFamily="34" charset="0"/>
+                <a:ea typeface="Calibri" pitchFamily="34" charset="-122"/>
+                <a:cs typeface="Calibri" pitchFamily="34" charset="-120"/>
+              </a:rPr>
+              <a:t>·  Verify remote work was done by a human</a:t>
+            </a:r>
+            <a:endParaRPr lang="en-US" sz="1200" dirty="0"/>
+          </a:p>
+        </p:txBody>
+      </p:sp>
+      <p:sp>
+        <p:nvSpPr>
+          <p:cNvPr id="19" name="Shape 17"/>
+          <p:cNvSpPr/>
+          <p:nvPr/>
+        </p:nvSpPr>
+        <p:spPr>
+          <a:xfrm>
+            <a:off x="411480" y="3557016"/>
+            <a:ext cx="4818888" cy="1051560"/>
           </a:xfrm>
           <a:prstGeom prst="roundRect">
             <a:avLst>
-              <a:gd name="adj" fmla="val 7143"/>
+              <a:gd name="adj" fmla="val 6957"/>
             </a:avLst>
           </a:prstGeom>
           <a:solidFill>
@@ -3984,14 +4544,39 @@
       </p:sp>
       <p:sp>
         <p:nvSpPr>
-          <p:cNvPr id="24" name="Text 22"/>
-          <p:cNvSpPr/>
-          <p:nvPr/>
-        </p:nvSpPr>
-        <p:spPr>
-          <a:xfrm>
-            <a:off x="557784" y="3730752"/>
-            <a:ext cx="2043684" cy="274320"/>
+          <p:cNvPr id="20" name="Shape 18"/>
+          <p:cNvSpPr/>
+          <p:nvPr/>
+        </p:nvSpPr>
+        <p:spPr>
+          <a:xfrm>
+            <a:off x="411480" y="3557016"/>
+            <a:ext cx="64008" cy="1051560"/>
+          </a:xfrm>
+          <a:prstGeom prst="rect">
+            <a:avLst/>
+          </a:prstGeom>
+          <a:solidFill>
+            <a:srgbClr val="E8B86D"/>
+          </a:solidFill>
+          <a:ln w="12700">
+            <a:solidFill>
+              <a:srgbClr val="E8B86D"/>
+            </a:solidFill>
+            <a:prstDash val="solid"/>
+          </a:ln>
+        </p:spPr>
+      </p:sp>
+      <p:sp>
+        <p:nvSpPr>
+          <p:cNvPr id="21" name="Text 19"/>
+          <p:cNvSpPr/>
+          <p:nvPr/>
+        </p:nvSpPr>
+        <p:spPr>
+          <a:xfrm>
+            <a:off x="612648" y="3685032"/>
+            <a:ext cx="640080" cy="795528"/>
           </a:xfrm>
           <a:prstGeom prst="rect">
             <a:avLst/>
@@ -4007,159 +4592,97 @@
               <a:buNone/>
             </a:pPr>
             <a:r>
-              <a:rPr lang="en-US" sz="1400" b="1" dirty="0">
-                <a:solidFill>
-                  <a:srgbClr val="FFFFFF"/>
+              <a:rPr lang="en-US" sz="1300" b="1" dirty="0">
+                <a:solidFill>
+                  <a:srgbClr val="E8B86D"/>
+                </a:solidFill>
+                <a:latin typeface="Consolas" pitchFamily="34" charset="0"/>
+                <a:ea typeface="Consolas" pitchFamily="34" charset="-122"/>
+                <a:cs typeface="Consolas" pitchFamily="34" charset="-120"/>
+              </a:rPr>
+              <a:t>ILE</a:t>
+            </a:r>
+            <a:endParaRPr lang="en-US" sz="1300" dirty="0"/>
+          </a:p>
+        </p:txBody>
+      </p:sp>
+      <p:sp>
+        <p:nvSpPr>
+          <p:cNvPr id="22" name="Text 20"/>
+          <p:cNvSpPr/>
+          <p:nvPr/>
+        </p:nvSpPr>
+        <p:spPr>
+          <a:xfrm>
+            <a:off x="1325880" y="3666744"/>
+            <a:ext cx="3721608" cy="832104"/>
+          </a:xfrm>
+          <a:prstGeom prst="rect">
+            <a:avLst/>
+          </a:prstGeom>
+          <a:noFill/>
+          <a:ln/>
+        </p:spPr>
+        <p:txBody>
+          <a:bodyPr wrap="square" lIns="0" tIns="0" rIns="0" bIns="0" rtlCol="0" anchor="ctr"/>
+          <a:lstStyle/>
+          <a:p>
+            <a:pPr indent="0" marL="0">
+              <a:spcAft>
+                <a:spcPts val="300"/>
+              </a:spcAft>
+              <a:buNone/>
+            </a:pPr>
+            <a:r>
+              <a:rPr lang="en-US" sz="1200" dirty="0">
+                <a:solidFill>
+                  <a:srgbClr val="C8D4F0"/>
                 </a:solidFill>
                 <a:latin typeface="Calibri" pitchFamily="34" charset="0"/>
                 <a:ea typeface="Calibri" pitchFamily="34" charset="-122"/>
                 <a:cs typeface="Calibri" pitchFamily="34" charset="-120"/>
               </a:rPr>
-              <a:t>Enablement</a:t>
-            </a:r>
-            <a:endParaRPr lang="en-US" sz="1400" dirty="0"/>
-          </a:p>
-        </p:txBody>
-      </p:sp>
-      <p:sp>
-        <p:nvSpPr>
-          <p:cNvPr id="25" name="Text 23"/>
-          <p:cNvSpPr/>
-          <p:nvPr/>
-        </p:nvSpPr>
-        <p:spPr>
-          <a:xfrm>
-            <a:off x="557784" y="4041648"/>
-            <a:ext cx="2043684" cy="438912"/>
-          </a:xfrm>
-          <a:prstGeom prst="rect">
-            <a:avLst/>
-          </a:prstGeom>
-          <a:noFill/>
-          <a:ln/>
-        </p:spPr>
-        <p:txBody>
-          <a:bodyPr wrap="square" lIns="0" tIns="0" rIns="0" bIns="0" rtlCol="0" anchor="ctr"/>
-          <a:lstStyle/>
+              <a:t>·  Replace take-homes with coached practice</a:t>
+            </a:r>
+            <a:endParaRPr lang="en-US" sz="1200" dirty="0"/>
+          </a:p>
           <a:p>
             <a:pPr indent="0" marL="0">
+              <a:spcAft>
+                <a:spcPts val="300"/>
+              </a:spcAft>
               <a:buNone/>
             </a:pPr>
             <a:r>
               <a:rPr lang="en-US" sz="1200" dirty="0">
                 <a:solidFill>
-                  <a:srgbClr val="8B93A7"/>
+                  <a:srgbClr val="C8D4F0"/>
                 </a:solidFill>
                 <a:latin typeface="Calibri" pitchFamily="34" charset="0"/>
                 <a:ea typeface="Calibri" pitchFamily="34" charset="-122"/>
                 <a:cs typeface="Calibri" pitchFamily="34" charset="-120"/>
               </a:rPr>
-              <a:t>Onboarding and sales/tech readiness scored on real work traces.</a:t>
+              <a:t>·  Close skill gaps found after assessment</a:t>
             </a:r>
             <a:endParaRPr lang="en-US" sz="1200" dirty="0"/>
           </a:p>
-        </p:txBody>
-      </p:sp>
-      <p:sp>
-        <p:nvSpPr>
-          <p:cNvPr id="26" name="Shape 24"/>
-          <p:cNvSpPr/>
-          <p:nvPr/>
-        </p:nvSpPr>
-        <p:spPr>
-          <a:xfrm>
-            <a:off x="2894076" y="3566160"/>
-            <a:ext cx="2336292" cy="1024128"/>
-          </a:xfrm>
-          <a:prstGeom prst="roundRect">
-            <a:avLst>
-              <a:gd name="adj" fmla="val 7143"/>
-            </a:avLst>
-          </a:prstGeom>
-          <a:solidFill>
-            <a:srgbClr val="181C26"/>
-          </a:solidFill>
-          <a:ln w="12700">
-            <a:solidFill>
-              <a:srgbClr val="2A3142"/>
-            </a:solidFill>
-            <a:prstDash val="solid"/>
-          </a:ln>
-        </p:spPr>
-      </p:sp>
-      <p:sp>
-        <p:nvSpPr>
-          <p:cNvPr id="27" name="Text 25"/>
-          <p:cNvSpPr/>
-          <p:nvPr/>
-        </p:nvSpPr>
-        <p:spPr>
-          <a:xfrm>
-            <a:off x="3040380" y="3730752"/>
-            <a:ext cx="2043684" cy="274320"/>
-          </a:xfrm>
-          <a:prstGeom prst="rect">
-            <a:avLst/>
-          </a:prstGeom>
-          <a:noFill/>
-          <a:ln/>
-        </p:spPr>
-        <p:txBody>
-          <a:bodyPr wrap="square" lIns="0" tIns="0" rIns="0" bIns="0" rtlCol="0" anchor="ctr"/>
-          <a:lstStyle/>
           <a:p>
             <a:pPr indent="0" marL="0">
-              <a:buNone/>
-            </a:pPr>
-            <a:r>
-              <a:rPr lang="en-US" sz="1400" b="1" dirty="0">
-                <a:solidFill>
-                  <a:srgbClr val="FFFFFF"/>
+              <a:spcAft>
+                <a:spcPts val="300"/>
+              </a:spcAft>
+              <a:buNone/>
+            </a:pPr>
+            <a:r>
+              <a:rPr lang="en-US" sz="1200" dirty="0">
+                <a:solidFill>
+                  <a:srgbClr val="C8D4F0"/>
                 </a:solidFill>
                 <a:latin typeface="Calibri" pitchFamily="34" charset="0"/>
                 <a:ea typeface="Calibri" pitchFamily="34" charset="-122"/>
                 <a:cs typeface="Calibri" pitchFamily="34" charset="-120"/>
               </a:rPr>
-              <a:t>Agent eval</a:t>
-            </a:r>
-            <a:endParaRPr lang="en-US" sz="1400" dirty="0"/>
-          </a:p>
-        </p:txBody>
-      </p:sp>
-      <p:sp>
-        <p:nvSpPr>
-          <p:cNvPr id="28" name="Text 26"/>
-          <p:cNvSpPr/>
-          <p:nvPr/>
-        </p:nvSpPr>
-        <p:spPr>
-          <a:xfrm>
-            <a:off x="3040380" y="4041648"/>
-            <a:ext cx="2043684" cy="438912"/>
-          </a:xfrm>
-          <a:prstGeom prst="rect">
-            <a:avLst/>
-          </a:prstGeom>
-          <a:noFill/>
-          <a:ln/>
-        </p:spPr>
-        <p:txBody>
-          <a:bodyPr wrap="square" lIns="0" tIns="0" rIns="0" bIns="0" rtlCol="0" anchor="ctr"/>
-          <a:lstStyle/>
-          <a:p>
-            <a:pPr indent="0" marL="0">
-              <a:buNone/>
-            </a:pPr>
-            <a:r>
-              <a:rPr lang="en-US" sz="1200" dirty="0">
-                <a:solidFill>
-                  <a:srgbClr val="8B93A7"/>
-                </a:solidFill>
-                <a:latin typeface="Calibri" pitchFamily="34" charset="0"/>
-                <a:ea typeface="Calibri" pitchFamily="34" charset="-122"/>
-                <a:cs typeface="Calibri" pitchFamily="34" charset="-120"/>
-              </a:rPr>
-              <a:t>Same PoW + interruption loop for tool-use and skill.md iteration.</a:t>
+              <a:t>·  Onboard teams with real job scenarios</a:t>
             </a:r>
             <a:endParaRPr lang="en-US" sz="1200" dirty="0"/>
           </a:p>

</xml_diff>

<commit_message>
Ship Knowledge config, embeddings projection, and Settings regions workflow.
Add knowledgecfg-v1-d64 trajectories with sidebar overlays and Knowledge distance on Embeddings, Custom Knowledge Regions (cohort + synthetic) in Settings, ILE guest links, eval history/self-scope, multi-cell block shapes, and production DB migrations for the new schema.
</commit_message>
<xml_diff>
--- a/docs/pitch/product-pitch.pptx
+++ b/docs/pitch/product-pitch.pptx
@@ -1489,7 +1489,7 @@
                 <a:ea typeface="Consolas" pitchFamily="34" charset="-122"/>
                 <a:cs typeface="Consolas" pitchFamily="34" charset="-120"/>
               </a:rPr>
-              <a:t>Brain config / proximity</a:t>
+              <a:t>Knowledge config / proximity</a:t>
             </a:r>
             <a:endParaRPr lang="en-US" sz="1100" dirty="0"/>
           </a:p>
@@ -1685,7 +1685,7 @@
                 <a:ea typeface="Consolas" pitchFamily="34" charset="-122"/>
                 <a:cs typeface="Consolas" pitchFamily="34" charset="-120"/>
               </a:rPr>
-              <a:t>BRAIN CONFIG MODEL</a:t>
+              <a:t>KNOWLEDGE CONFIG MODEL</a:t>
             </a:r>
             <a:endParaRPr lang="en-US" sz="1000" dirty="0"/>
           </a:p>
@@ -1724,7 +1724,7 @@
                 <a:ea typeface="Calibri" pitchFamily="34" charset="-122"/>
                 <a:cs typeface="Calibri" pitchFamily="34" charset="-120"/>
               </a:rPr>
-              <a:t>Holistic state of mind — not a scoreboard of right/wrong items.</a:t>
+              <a:t>Holistic representation of knowledge that extends beyond one's brain to the tools we rely on as well — not a scoreboard of right/wrong items.</a:t>
             </a:r>
             <a:endParaRPr lang="en-US" sz="1300" dirty="0"/>
           </a:p>

</xml_diff>